<commit_message>
Upload final presentation slides
</commit_message>
<xml_diff>
--- a/vba-sap-document-batch-export/Resources/Project_presentation_slides.pptx
+++ b/vba-sap-document-batch-export/Resources/Project_presentation_slides.pptx
@@ -306,7 +306,7 @@
       </p15:sldGuideLst>
     </p:ext>
     <p:ext uri="GoogleSlidesCustomDataVersion2">
-      <go:slidesCustomData xmlns:go="http://customooxmlschemas.google.com/" r:id="rId40" roundtripDataSignature="AMtx7mjeRpk5SY0XNKnYHbAOew1fsA+clw=="/>
+      <go:slidesCustomData xmlns:go="http://customooxmlschemas.google.com/" r:id="rId40" roundtripDataSignature="AMtx7mgTbYRRx7TIxzsyNItfu70FqUx9Pg=="/>
     </p:ext>
   </p:extLst>
 </p:presentation>
@@ -2282,7 +2282,7 @@
   <p:cSld>
     <p:spTree>
       <p:nvGrpSpPr>
-        <p:cNvPr id="245" name="Shape 245"/>
+        <p:cNvPr id="249" name="Shape 249"/>
         <p:cNvGrpSpPr/>
         <p:nvPr/>
       </p:nvGrpSpPr>
@@ -2296,7 +2296,7 @@
       </p:grpSpPr>
       <p:sp>
         <p:nvSpPr>
-          <p:cNvPr id="246" name="Google Shape;246;p9:notes"/>
+          <p:cNvPr id="250" name="Google Shape;250;p9:notes"/>
           <p:cNvSpPr txBox="1"/>
           <p:nvPr>
             <p:ph idx="1" type="body"/>
@@ -2343,7 +2343,7 @@
       </p:sp>
       <p:sp>
         <p:nvSpPr>
-          <p:cNvPr id="247" name="Google Shape;247;p9:notes"/>
+          <p:cNvPr id="251" name="Google Shape;251;p9:notes"/>
           <p:cNvSpPr/>
           <p:nvPr>
             <p:ph idx="2" type="sldImg"/>
@@ -20427,7 +20427,7 @@
             <a:tbl>
               <a:tblPr bandRow="1" firstRow="1">
                 <a:noFill/>
-                <a:tableStyleId>{43D933BC-B50A-4BFB-B1E9-065E42BD3DCA}</a:tableStyleId>
+                <a:tableStyleId>{C4AB5C4D-3846-4573-9431-B61F419FFCB4}</a:tableStyleId>
               </a:tblPr>
               <a:tblGrid>
                 <a:gridCol w="1228725"/>
@@ -25319,7 +25319,7 @@
         </p:blipFill>
         <p:spPr>
           <a:xfrm>
-            <a:off x="771525" y="2747069"/>
+            <a:off x="1335850" y="1157743"/>
             <a:ext cx="2519362" cy="2002035"/>
           </a:xfrm>
           <a:prstGeom prst="rect">
@@ -25346,7 +25346,7 @@
         </p:blipFill>
         <p:spPr>
           <a:xfrm>
-            <a:off x="3481387" y="2747069"/>
+            <a:off x="4836312" y="1157743"/>
             <a:ext cx="2519362" cy="2002035"/>
           </a:xfrm>
           <a:prstGeom prst="rect">
@@ -25373,7 +25373,7 @@
         </p:blipFill>
         <p:spPr>
           <a:xfrm>
-            <a:off x="6191250" y="2747069"/>
+            <a:off x="3042100" y="3698219"/>
             <a:ext cx="2519362" cy="2002035"/>
           </a:xfrm>
           <a:prstGeom prst="rect">
@@ -25400,7 +25400,7 @@
         </p:blipFill>
         <p:spPr>
           <a:xfrm>
-            <a:off x="8901112" y="2747069"/>
+            <a:off x="6698862" y="3698219"/>
             <a:ext cx="2519362" cy="2002035"/>
           </a:xfrm>
           <a:prstGeom prst="rect">
@@ -25420,7 +25420,7 @@
         </p:nvSpPr>
         <p:spPr>
           <a:xfrm>
-            <a:off x="990600" y="3451919"/>
+            <a:off x="1554925" y="1862593"/>
             <a:ext cx="2185200" cy="207900"/>
           </a:xfrm>
           <a:prstGeom prst="rect">
@@ -25486,7 +25486,7 @@
         </p:nvSpPr>
         <p:spPr>
           <a:xfrm>
-            <a:off x="933000" y="3756725"/>
+            <a:off x="1497325" y="2167399"/>
             <a:ext cx="2300400" cy="864300"/>
           </a:xfrm>
           <a:prstGeom prst="rect">
@@ -25552,7 +25552,7 @@
         </p:nvSpPr>
         <p:spPr>
           <a:xfrm>
-            <a:off x="3700462" y="3451919"/>
+            <a:off x="5055387" y="1862593"/>
             <a:ext cx="2185200" cy="207900"/>
           </a:xfrm>
           <a:prstGeom prst="rect">
@@ -25618,7 +25618,7 @@
         </p:nvSpPr>
         <p:spPr>
           <a:xfrm>
-            <a:off x="3700462" y="3756719"/>
+            <a:off x="5055387" y="2167393"/>
             <a:ext cx="2081100" cy="864300"/>
           </a:xfrm>
           <a:prstGeom prst="rect">
@@ -25684,7 +25684,7 @@
         </p:nvSpPr>
         <p:spPr>
           <a:xfrm>
-            <a:off x="6410325" y="3451919"/>
+            <a:off x="3261175" y="4403069"/>
             <a:ext cx="2185200" cy="207900"/>
           </a:xfrm>
           <a:prstGeom prst="rect">
@@ -25750,7 +25750,7 @@
         </p:nvSpPr>
         <p:spPr>
           <a:xfrm>
-            <a:off x="6410325" y="3756719"/>
+            <a:off x="3261175" y="4707869"/>
             <a:ext cx="2081100" cy="864300"/>
           </a:xfrm>
           <a:prstGeom prst="rect">
@@ -25816,7 +25816,7 @@
         </p:nvSpPr>
         <p:spPr>
           <a:xfrm>
-            <a:off x="9120187" y="3451919"/>
+            <a:off x="6917937" y="4403069"/>
             <a:ext cx="2185200" cy="207900"/>
           </a:xfrm>
           <a:prstGeom prst="rect">
@@ -25882,7 +25882,7 @@
         </p:nvSpPr>
         <p:spPr>
           <a:xfrm>
-            <a:off x="9120187" y="3756719"/>
+            <a:off x="6917937" y="4707869"/>
             <a:ext cx="2081100" cy="864300"/>
           </a:xfrm>
           <a:prstGeom prst="rect">
@@ -25955,7 +25955,7 @@
         </p:blipFill>
         <p:spPr>
           <a:xfrm>
-            <a:off x="990600" y="2994719"/>
+            <a:off x="1554925" y="1405393"/>
             <a:ext cx="361950" cy="285750"/>
           </a:xfrm>
           <a:prstGeom prst="rect">
@@ -25982,7 +25982,7 @@
         </p:blipFill>
         <p:spPr>
           <a:xfrm>
-            <a:off x="3700462" y="2994719"/>
+            <a:off x="5055387" y="1405393"/>
             <a:ext cx="361950" cy="285750"/>
           </a:xfrm>
           <a:prstGeom prst="rect">
@@ -26009,7 +26009,7 @@
         </p:blipFill>
         <p:spPr>
           <a:xfrm>
-            <a:off x="6410325" y="2994719"/>
+            <a:off x="3261175" y="3945869"/>
             <a:ext cx="285750" cy="285750"/>
           </a:xfrm>
           <a:prstGeom prst="rect">
@@ -26036,7 +26036,7 @@
         </p:blipFill>
         <p:spPr>
           <a:xfrm>
-            <a:off x="9120187" y="2994719"/>
+            <a:off x="6917937" y="3945869"/>
             <a:ext cx="361950" cy="285750"/>
           </a:xfrm>
           <a:prstGeom prst="rect">
@@ -26239,6 +26239,204 @@
           </a:p>
         </p:txBody>
       </p:sp>
+      <p:pic>
+        <p:nvPicPr>
+          <p:cNvPr descr="image.png" id="245" name="Google Shape;245;p8"/>
+          <p:cNvPicPr preferRelativeResize="0"/>
+          <p:nvPr/>
+        </p:nvPicPr>
+        <p:blipFill rotWithShape="1">
+          <a:blip r:embed="rId4">
+            <a:alphaModFix/>
+          </a:blip>
+          <a:srcRect b="0" l="0" r="0" t="0"/>
+          <a:stretch/>
+        </p:blipFill>
+        <p:spPr>
+          <a:xfrm>
+            <a:off x="8336787" y="1157744"/>
+            <a:ext cx="2519362" cy="2002035"/>
+          </a:xfrm>
+          <a:prstGeom prst="rect">
+            <a:avLst/>
+          </a:prstGeom>
+          <a:noFill/>
+          <a:ln>
+            <a:noFill/>
+          </a:ln>
+        </p:spPr>
+      </p:pic>
+      <p:sp>
+        <p:nvSpPr>
+          <p:cNvPr id="246" name="Google Shape;246;p8"/>
+          <p:cNvSpPr txBox="1"/>
+          <p:nvPr/>
+        </p:nvSpPr>
+        <p:spPr>
+          <a:xfrm>
+            <a:off x="8555862" y="1862594"/>
+            <a:ext cx="2185200" cy="207900"/>
+          </a:xfrm>
+          <a:prstGeom prst="rect">
+            <a:avLst/>
+          </a:prstGeom>
+          <a:noFill/>
+          <a:ln>
+            <a:noFill/>
+          </a:ln>
+        </p:spPr>
+        <p:txBody>
+          <a:bodyPr anchorCtr="0" anchor="t" bIns="0" lIns="0" spcFirstLastPara="1" rIns="0" wrap="square" tIns="0">
+            <a:spAutoFit/>
+          </a:bodyPr>
+          <a:lstStyle/>
+          <a:p>
+            <a:pPr indent="0" lvl="0" marL="0" marR="0" rtl="0" algn="l">
+              <a:lnSpc>
+                <a:spcPct val="100000"/>
+              </a:lnSpc>
+              <a:spcBef>
+                <a:spcPts val="0"/>
+              </a:spcBef>
+              <a:spcAft>
+                <a:spcPts val="0"/>
+              </a:spcAft>
+              <a:buClr>
+                <a:srgbClr val="000000"/>
+              </a:buClr>
+              <a:buSzPts val="1350"/>
+              <a:buFont typeface="Arial"/>
+              <a:buNone/>
+            </a:pPr>
+            <a:r>
+              <a:rPr b="0" i="0" lang="en-US" sz="1350" u="none" cap="none" strike="noStrike">
+                <a:solidFill>
+                  <a:srgbClr val="FFFFFF"/>
+                </a:solidFill>
+                <a:latin typeface="Montserrat SemiBold"/>
+                <a:ea typeface="Montserrat SemiBold"/>
+                <a:cs typeface="Montserrat SemiBold"/>
+                <a:sym typeface="Montserrat SemiBold"/>
+              </a:rPr>
+              <a:t>mod</a:t>
+            </a:r>
+            <a:r>
+              <a:rPr lang="en-US" sz="1350">
+                <a:solidFill>
+                  <a:srgbClr val="FFFFFF"/>
+                </a:solidFill>
+                <a:latin typeface="Montserrat SemiBold"/>
+                <a:ea typeface="Montserrat SemiBold"/>
+                <a:cs typeface="Montserrat SemiBold"/>
+                <a:sym typeface="Montserrat SemiBold"/>
+              </a:rPr>
+              <a:t>OLE_Shield</a:t>
+            </a:r>
+            <a:endParaRPr b="0" i="0" sz="1400" u="none" cap="none" strike="noStrike">
+              <a:solidFill>
+                <a:srgbClr val="000000"/>
+              </a:solidFill>
+              <a:latin typeface="Arial"/>
+              <a:ea typeface="Arial"/>
+              <a:cs typeface="Arial"/>
+              <a:sym typeface="Arial"/>
+            </a:endParaRPr>
+          </a:p>
+        </p:txBody>
+      </p:sp>
+      <p:sp>
+        <p:nvSpPr>
+          <p:cNvPr id="247" name="Google Shape;247;p8"/>
+          <p:cNvSpPr txBox="1"/>
+          <p:nvPr/>
+        </p:nvSpPr>
+        <p:spPr>
+          <a:xfrm>
+            <a:off x="8555838" y="2167375"/>
+            <a:ext cx="2249400" cy="864300"/>
+          </a:xfrm>
+          <a:prstGeom prst="rect">
+            <a:avLst/>
+          </a:prstGeom>
+          <a:noFill/>
+          <a:ln>
+            <a:noFill/>
+          </a:ln>
+        </p:spPr>
+        <p:txBody>
+          <a:bodyPr anchorCtr="0" anchor="t" bIns="0" lIns="0" spcFirstLastPara="1" rIns="0" wrap="square" tIns="0">
+            <a:spAutoFit/>
+          </a:bodyPr>
+          <a:lstStyle/>
+          <a:p>
+            <a:pPr indent="0" lvl="0" marL="0" marR="0" rtl="0" algn="l">
+              <a:lnSpc>
+                <a:spcPct val="144952"/>
+              </a:lnSpc>
+              <a:spcBef>
+                <a:spcPts val="0"/>
+              </a:spcBef>
+              <a:spcAft>
+                <a:spcPts val="0"/>
+              </a:spcAft>
+              <a:buClr>
+                <a:srgbClr val="000000"/>
+              </a:buClr>
+              <a:buSzPts val="1050"/>
+              <a:buFont typeface="Arial"/>
+              <a:buNone/>
+            </a:pPr>
+            <a:r>
+              <a:rPr lang="en-US" sz="1050">
+                <a:solidFill>
+                  <a:srgbClr val="CDD6F4"/>
+                </a:solidFill>
+                <a:latin typeface="Inter"/>
+                <a:ea typeface="Inter"/>
+                <a:cs typeface="Inter"/>
+                <a:sym typeface="Inter"/>
+              </a:rPr>
+              <a:t>Provides temporary OLE message handling during long-running SAP GUI automation to improve unattended execution. </a:t>
+            </a:r>
+            <a:endParaRPr b="0" i="0" sz="1400" u="none" cap="none" strike="noStrike">
+              <a:solidFill>
+                <a:srgbClr val="000000"/>
+              </a:solidFill>
+              <a:latin typeface="Arial"/>
+              <a:ea typeface="Arial"/>
+              <a:cs typeface="Arial"/>
+              <a:sym typeface="Arial"/>
+            </a:endParaRPr>
+          </a:p>
+        </p:txBody>
+      </p:sp>
+      <p:pic>
+        <p:nvPicPr>
+          <p:cNvPr descr="image.png" id="248" name="Google Shape;248;p8"/>
+          <p:cNvPicPr preferRelativeResize="0"/>
+          <p:nvPr/>
+        </p:nvPicPr>
+        <p:blipFill rotWithShape="1">
+          <a:blip r:embed="rId10">
+            <a:alphaModFix/>
+          </a:blip>
+          <a:srcRect b="0" l="0" r="0" t="0"/>
+          <a:stretch/>
+        </p:blipFill>
+        <p:spPr>
+          <a:xfrm>
+            <a:off x="8555825" y="1376340"/>
+            <a:ext cx="361950" cy="343853"/>
+          </a:xfrm>
+          <a:prstGeom prst="rect">
+            <a:avLst/>
+          </a:prstGeom>
+          <a:noFill/>
+          <a:ln>
+            <a:noFill/>
+          </a:ln>
+        </p:spPr>
+      </p:pic>
     </p:spTree>
   </p:cSld>
   <p:clrMapOvr>
@@ -26259,7 +26457,7 @@
     </p:bg>
     <p:spTree>
       <p:nvGrpSpPr>
-        <p:cNvPr id="248" name="Shape 248"/>
+        <p:cNvPr id="252" name="Shape 252"/>
         <p:cNvGrpSpPr/>
         <p:nvPr/>
       </p:nvGrpSpPr>
@@ -26273,7 +26471,7 @@
       </p:grpSpPr>
       <p:pic>
         <p:nvPicPr>
-          <p:cNvPr descr="image.png" id="249" name="Google Shape;249;p9"/>
+          <p:cNvPr descr="image.png" id="253" name="Google Shape;253;p9"/>
           <p:cNvPicPr preferRelativeResize="0"/>
           <p:nvPr/>
         </p:nvPicPr>
@@ -26300,7 +26498,7 @@
       </p:pic>
       <p:sp>
         <p:nvSpPr>
-          <p:cNvPr id="250" name="Google Shape;250;p9"/>
+          <p:cNvPr id="254" name="Google Shape;254;p9"/>
           <p:cNvSpPr txBox="1"/>
           <p:nvPr/>
         </p:nvSpPr>
@@ -26351,342 +26549,6 @@
                 <a:sym typeface="Montserrat SemiBold"/>
               </a:rPr>
               <a:t>Preventing "Server Busy" Deadlocks</a:t>
-            </a:r>
-            <a:endParaRPr b="0" i="0" sz="1400" u="none" cap="none" strike="noStrike">
-              <a:solidFill>
-                <a:srgbClr val="000000"/>
-              </a:solidFill>
-              <a:latin typeface="Arial"/>
-              <a:ea typeface="Arial"/>
-              <a:cs typeface="Arial"/>
-              <a:sym typeface="Arial"/>
-            </a:endParaRPr>
-          </a:p>
-        </p:txBody>
-      </p:sp>
-      <p:sp>
-        <p:nvSpPr>
-          <p:cNvPr id="251" name="Google Shape;251;p9"/>
-          <p:cNvSpPr txBox="1"/>
-          <p:nvPr/>
-        </p:nvSpPr>
-        <p:spPr>
-          <a:xfrm>
-            <a:off x="771525" y="2221408"/>
-            <a:ext cx="5110200" cy="471000"/>
-          </a:xfrm>
-          <a:prstGeom prst="rect">
-            <a:avLst/>
-          </a:prstGeom>
-          <a:noFill/>
-          <a:ln>
-            <a:noFill/>
-          </a:ln>
-        </p:spPr>
-        <p:txBody>
-          <a:bodyPr anchorCtr="0" anchor="t" bIns="0" lIns="0" spcFirstLastPara="1" rIns="0" wrap="square" tIns="0">
-            <a:spAutoFit/>
-          </a:bodyPr>
-          <a:lstStyle/>
-          <a:p>
-            <a:pPr indent="0" lvl="0" marL="0" marR="0" rtl="0" algn="l">
-              <a:lnSpc>
-                <a:spcPct val="155000"/>
-              </a:lnSpc>
-              <a:spcBef>
-                <a:spcPts val="0"/>
-              </a:spcBef>
-              <a:spcAft>
-                <a:spcPts val="0"/>
-              </a:spcAft>
-              <a:buClr>
-                <a:srgbClr val="000000"/>
-              </a:buClr>
-              <a:buSzPts val="1200"/>
-              <a:buFont typeface="Arial"/>
-              <a:buNone/>
-            </a:pPr>
-            <a:r>
-              <a:rPr b="0" i="0" lang="en-US" sz="1200" u="none" cap="none" strike="noStrike">
-                <a:solidFill>
-                  <a:srgbClr val="CDD6F4"/>
-                </a:solidFill>
-                <a:latin typeface="Inter"/>
-                <a:ea typeface="Inter"/>
-                <a:cs typeface="Inter"/>
-                <a:sym typeface="Inter"/>
-              </a:rPr>
-              <a:t>Bypassing standard Windows timeout barriers during slow SAP database queries:</a:t>
-            </a:r>
-            <a:endParaRPr b="0" i="0" sz="1400" u="none" cap="none" strike="noStrike">
-              <a:solidFill>
-                <a:srgbClr val="000000"/>
-              </a:solidFill>
-              <a:latin typeface="Arial"/>
-              <a:ea typeface="Arial"/>
-              <a:cs typeface="Arial"/>
-              <a:sym typeface="Arial"/>
-            </a:endParaRPr>
-          </a:p>
-        </p:txBody>
-      </p:sp>
-      <p:sp>
-        <p:nvSpPr>
-          <p:cNvPr id="252" name="Google Shape;252;p9"/>
-          <p:cNvSpPr txBox="1"/>
-          <p:nvPr/>
-        </p:nvSpPr>
-        <p:spPr>
-          <a:xfrm>
-            <a:off x="1104900" y="2808089"/>
-            <a:ext cx="4776900" cy="471000"/>
-          </a:xfrm>
-          <a:prstGeom prst="rect">
-            <a:avLst/>
-          </a:prstGeom>
-          <a:noFill/>
-          <a:ln>
-            <a:noFill/>
-          </a:ln>
-        </p:spPr>
-        <p:txBody>
-          <a:bodyPr anchorCtr="0" anchor="t" bIns="0" lIns="0" spcFirstLastPara="1" rIns="0" wrap="square" tIns="0">
-            <a:spAutoFit/>
-          </a:bodyPr>
-          <a:lstStyle/>
-          <a:p>
-            <a:pPr indent="0" lvl="0" marL="0" marR="0" rtl="0" algn="l">
-              <a:lnSpc>
-                <a:spcPct val="155000"/>
-              </a:lnSpc>
-              <a:spcBef>
-                <a:spcPts val="0"/>
-              </a:spcBef>
-              <a:spcAft>
-                <a:spcPts val="0"/>
-              </a:spcAft>
-              <a:buClr>
-                <a:srgbClr val="000000"/>
-              </a:buClr>
-              <a:buSzPts val="1200"/>
-              <a:buFont typeface="Arial"/>
-              <a:buNone/>
-            </a:pPr>
-            <a:r>
-              <a:rPr b="1" i="0" lang="en-US" sz="1200" u="none" cap="none" strike="noStrike">
-                <a:solidFill>
-                  <a:srgbClr val="FFFFFF"/>
-                </a:solidFill>
-                <a:latin typeface="Inter"/>
-                <a:ea typeface="Inter"/>
-                <a:cs typeface="Inter"/>
-                <a:sym typeface="Inter"/>
-              </a:rPr>
-              <a:t>The Bottleneck:</a:t>
-            </a:r>
-            <a:r>
-              <a:rPr b="0" i="0" lang="en-US" sz="1200" u="none" cap="none" strike="noStrike">
-                <a:solidFill>
-                  <a:srgbClr val="CDD6F4"/>
-                </a:solidFill>
-                <a:latin typeface="Inter"/>
-                <a:ea typeface="Inter"/>
-                <a:cs typeface="Inter"/>
-                <a:sym typeface="Inter"/>
-              </a:rPr>
-              <a:t> Database delays or network latency when retrieving PDFs blocks Excel's synchronous execution thread.</a:t>
-            </a:r>
-            <a:endParaRPr b="0" i="0" sz="1400" u="none" cap="none" strike="noStrike">
-              <a:solidFill>
-                <a:srgbClr val="000000"/>
-              </a:solidFill>
-              <a:latin typeface="Arial"/>
-              <a:ea typeface="Arial"/>
-              <a:cs typeface="Arial"/>
-              <a:sym typeface="Arial"/>
-            </a:endParaRPr>
-          </a:p>
-        </p:txBody>
-      </p:sp>
-      <p:sp>
-        <p:nvSpPr>
-          <p:cNvPr id="253" name="Google Shape;253;p9"/>
-          <p:cNvSpPr txBox="1"/>
-          <p:nvPr/>
-        </p:nvSpPr>
-        <p:spPr>
-          <a:xfrm>
-            <a:off x="1104900" y="3394769"/>
-            <a:ext cx="4776900" cy="757200"/>
-          </a:xfrm>
-          <a:prstGeom prst="rect">
-            <a:avLst/>
-          </a:prstGeom>
-          <a:noFill/>
-          <a:ln>
-            <a:noFill/>
-          </a:ln>
-        </p:spPr>
-        <p:txBody>
-          <a:bodyPr anchorCtr="0" anchor="t" bIns="0" lIns="0" spcFirstLastPara="1" rIns="0" wrap="square" tIns="0">
-            <a:spAutoFit/>
-          </a:bodyPr>
-          <a:lstStyle/>
-          <a:p>
-            <a:pPr indent="0" lvl="0" marL="0" marR="0" rtl="0" algn="l">
-              <a:lnSpc>
-                <a:spcPct val="155000"/>
-              </a:lnSpc>
-              <a:spcBef>
-                <a:spcPts val="0"/>
-              </a:spcBef>
-              <a:spcAft>
-                <a:spcPts val="0"/>
-              </a:spcAft>
-              <a:buClr>
-                <a:srgbClr val="000000"/>
-              </a:buClr>
-              <a:buSzPts val="1200"/>
-              <a:buFont typeface="Arial"/>
-              <a:buNone/>
-            </a:pPr>
-            <a:r>
-              <a:rPr b="1" i="0" lang="en-US" sz="1200" u="none" cap="none" strike="noStrike">
-                <a:solidFill>
-                  <a:srgbClr val="FFFFFF"/>
-                </a:solidFill>
-                <a:latin typeface="Inter"/>
-                <a:ea typeface="Inter"/>
-                <a:cs typeface="Inter"/>
-                <a:sym typeface="Inter"/>
-              </a:rPr>
-              <a:t>The OLE Trigger:</a:t>
-            </a:r>
-            <a:r>
-              <a:rPr b="0" i="0" lang="en-US" sz="1200" u="none" cap="none" strike="noStrike">
-                <a:solidFill>
-                  <a:srgbClr val="CDD6F4"/>
-                </a:solidFill>
-                <a:latin typeface="Inter"/>
-                <a:ea typeface="Inter"/>
-                <a:cs typeface="Inter"/>
-                <a:sym typeface="Inter"/>
-              </a:rPr>
-              <a:t> If Excel blocks for over 30 seconds, Windows forces a modal alert: </a:t>
-            </a:r>
-            <a:r>
-              <a:rPr b="0" i="1" lang="en-US" sz="1200" u="none" cap="none" strike="noStrike">
-                <a:solidFill>
-                  <a:srgbClr val="CDD6F4"/>
-                </a:solidFill>
-                <a:latin typeface="Inter"/>
-                <a:ea typeface="Inter"/>
-                <a:cs typeface="Inter"/>
-                <a:sym typeface="Inter"/>
-              </a:rPr>
-              <a:t>"Microsoft Excel is waiting for another application…"</a:t>
-            </a:r>
-            <a:r>
-              <a:rPr b="0" i="0" lang="en-US" sz="1200" u="none" cap="none" strike="noStrike">
-                <a:solidFill>
-                  <a:srgbClr val="CDD6F4"/>
-                </a:solidFill>
-                <a:latin typeface="Inter"/>
-                <a:ea typeface="Inter"/>
-                <a:cs typeface="Inter"/>
-                <a:sym typeface="Inter"/>
-              </a:rPr>
-              <a:t>, freezing the unattended script.</a:t>
-            </a:r>
-            <a:endParaRPr b="0" i="0" sz="1400" u="none" cap="none" strike="noStrike">
-              <a:solidFill>
-                <a:srgbClr val="000000"/>
-              </a:solidFill>
-              <a:latin typeface="Arial"/>
-              <a:ea typeface="Arial"/>
-              <a:cs typeface="Arial"/>
-              <a:sym typeface="Arial"/>
-            </a:endParaRPr>
-          </a:p>
-        </p:txBody>
-      </p:sp>
-      <p:sp>
-        <p:nvSpPr>
-          <p:cNvPr id="254" name="Google Shape;254;p9"/>
-          <p:cNvSpPr txBox="1"/>
-          <p:nvPr/>
-        </p:nvSpPr>
-        <p:spPr>
-          <a:xfrm>
-            <a:off x="1104900" y="4217640"/>
-            <a:ext cx="4776900" cy="757200"/>
-          </a:xfrm>
-          <a:prstGeom prst="rect">
-            <a:avLst/>
-          </a:prstGeom>
-          <a:noFill/>
-          <a:ln>
-            <a:noFill/>
-          </a:ln>
-        </p:spPr>
-        <p:txBody>
-          <a:bodyPr anchorCtr="0" anchor="t" bIns="0" lIns="0" spcFirstLastPara="1" rIns="0" wrap="square" tIns="0">
-            <a:spAutoFit/>
-          </a:bodyPr>
-          <a:lstStyle/>
-          <a:p>
-            <a:pPr indent="0" lvl="0" marL="0" marR="0" rtl="0" algn="l">
-              <a:lnSpc>
-                <a:spcPct val="155000"/>
-              </a:lnSpc>
-              <a:spcBef>
-                <a:spcPts val="0"/>
-              </a:spcBef>
-              <a:spcAft>
-                <a:spcPts val="0"/>
-              </a:spcAft>
-              <a:buClr>
-                <a:srgbClr val="000000"/>
-              </a:buClr>
-              <a:buSzPts val="1200"/>
-              <a:buFont typeface="Arial"/>
-              <a:buNone/>
-            </a:pPr>
-            <a:r>
-              <a:rPr b="1" i="0" lang="en-US" sz="1200" u="none" cap="none" strike="noStrike">
-                <a:solidFill>
-                  <a:srgbClr val="FFFFFF"/>
-                </a:solidFill>
-                <a:latin typeface="Inter"/>
-                <a:ea typeface="Inter"/>
-                <a:cs typeface="Inter"/>
-                <a:sym typeface="Inter"/>
-              </a:rPr>
-              <a:t>Solution:</a:t>
-            </a:r>
-            <a:r>
-              <a:rPr b="0" i="0" lang="en-US" sz="1200" u="none" cap="none" strike="noStrike">
-                <a:solidFill>
-                  <a:srgbClr val="CDD6F4"/>
-                </a:solidFill>
-                <a:latin typeface="Inter"/>
-                <a:ea typeface="Inter"/>
-                <a:cs typeface="Inter"/>
-                <a:sym typeface="Inter"/>
-              </a:rPr>
-              <a:t> </a:t>
-            </a:r>
-            <a:r>
-              <a:rPr lang="en-US" sz="1200">
-                <a:solidFill>
-                  <a:srgbClr val="CDD6F4"/>
-                </a:solidFill>
-                <a:latin typeface="Inter"/>
-                <a:ea typeface="Inter"/>
-                <a:cs typeface="Inter"/>
-                <a:sym typeface="Inter"/>
-              </a:rPr>
-              <a:t>Implemented Windows API–based detection to identify and dismiss the Windows OLE dialog before continuing unattended SAP automation. </a:t>
             </a:r>
             <a:endParaRPr b="0" i="0" sz="1400" u="none" cap="none" strike="noStrike">
               <a:solidFill>
@@ -26708,8 +26570,8 @@
         </p:nvSpPr>
         <p:spPr>
           <a:xfrm>
-            <a:off x="1104900" y="5346709"/>
-            <a:ext cx="4776900" cy="757200"/>
+            <a:off x="771525" y="2221408"/>
+            <a:ext cx="5110200" cy="471000"/>
           </a:xfrm>
           <a:prstGeom prst="rect">
             <a:avLst/>
@@ -26743,28 +26605,286 @@
               <a:buNone/>
             </a:pPr>
             <a:r>
-              <a:rPr b="1" i="0" lang="en-US" sz="1200" u="none" cap="none" strike="noStrike">
-                <a:solidFill>
-                  <a:srgbClr val="FFFFFF"/>
+              <a:rPr b="0" i="0" lang="en-US" sz="1200" u="none" cap="none" strike="noStrike">
+                <a:solidFill>
+                  <a:srgbClr val="CDD6F4"/>
                 </a:solidFill>
                 <a:latin typeface="Inter"/>
                 <a:ea typeface="Inter"/>
                 <a:cs typeface="Inter"/>
                 <a:sym typeface="Inter"/>
               </a:rPr>
-              <a:t>Instant Auto-Enter:</a:t>
+              <a:t>Bypassing standard Windows timeout barriers during slow SAP database queries:</a:t>
             </a:r>
+            <a:endParaRPr b="0" i="0" sz="1400" u="none" cap="none" strike="noStrike">
+              <a:solidFill>
+                <a:srgbClr val="000000"/>
+              </a:solidFill>
+              <a:latin typeface="Arial"/>
+              <a:ea typeface="Arial"/>
+              <a:cs typeface="Arial"/>
+              <a:sym typeface="Arial"/>
+            </a:endParaRPr>
+          </a:p>
+        </p:txBody>
+      </p:sp>
+      <p:sp>
+        <p:nvSpPr>
+          <p:cNvPr id="256" name="Google Shape;256;p9"/>
+          <p:cNvSpPr txBox="1"/>
+          <p:nvPr/>
+        </p:nvSpPr>
+        <p:spPr>
+          <a:xfrm>
+            <a:off x="1104900" y="2808089"/>
+            <a:ext cx="4776900" cy="471000"/>
+          </a:xfrm>
+          <a:prstGeom prst="rect">
+            <a:avLst/>
+          </a:prstGeom>
+          <a:noFill/>
+          <a:ln>
+            <a:noFill/>
+          </a:ln>
+        </p:spPr>
+        <p:txBody>
+          <a:bodyPr anchorCtr="0" anchor="t" bIns="0" lIns="0" spcFirstLastPara="1" rIns="0" wrap="square" tIns="0">
+            <a:spAutoFit/>
+          </a:bodyPr>
+          <a:lstStyle/>
+          <a:p>
+            <a:pPr indent="0" lvl="0" marL="0" marR="0" rtl="0" algn="l">
+              <a:lnSpc>
+                <a:spcPct val="155000"/>
+              </a:lnSpc>
+              <a:spcBef>
+                <a:spcPts val="0"/>
+              </a:spcBef>
+              <a:spcAft>
+                <a:spcPts val="0"/>
+              </a:spcAft>
+              <a:buClr>
+                <a:srgbClr val="000000"/>
+              </a:buClr>
+              <a:buSzPts val="1200"/>
+              <a:buFont typeface="Arial"/>
+              <a:buNone/>
+            </a:pPr>
             <a:r>
-              <a:rPr b="0" i="0" lang="en-US" sz="1200" u="none" cap="none" strike="noStrike">
-                <a:solidFill>
-                  <a:srgbClr val="CDD6F4"/>
+              <a:rPr b="1" i="0" lang="en-US" sz="1200" u="none" cap="none" strike="noStrike">
+                <a:solidFill>
+                  <a:srgbClr val="FFFFFF"/>
                 </a:solidFill>
                 <a:latin typeface="Inter"/>
                 <a:ea typeface="Inter"/>
                 <a:cs typeface="Inter"/>
                 <a:sym typeface="Inter"/>
               </a:rPr>
-              <a:t> Detects and automatically dismisses the Windows OLE dialog when it appears before the "Save As PDF" dialog, preventing the unattended automation from stalling. </a:t>
+              <a:t>The Bottleneck:</a:t>
+            </a:r>
+            <a:r>
+              <a:rPr b="0" i="0" lang="en-US" sz="1200" u="none" cap="none" strike="noStrike">
+                <a:solidFill>
+                  <a:srgbClr val="CDD6F4"/>
+                </a:solidFill>
+                <a:latin typeface="Inter"/>
+                <a:ea typeface="Inter"/>
+                <a:cs typeface="Inter"/>
+                <a:sym typeface="Inter"/>
+              </a:rPr>
+              <a:t> Database delays or network latency when retrieving PDFs blocks Excel's synchronous execution thread.</a:t>
+            </a:r>
+            <a:endParaRPr b="0" i="0" sz="1400" u="none" cap="none" strike="noStrike">
+              <a:solidFill>
+                <a:srgbClr val="000000"/>
+              </a:solidFill>
+              <a:latin typeface="Arial"/>
+              <a:ea typeface="Arial"/>
+              <a:cs typeface="Arial"/>
+              <a:sym typeface="Arial"/>
+            </a:endParaRPr>
+          </a:p>
+        </p:txBody>
+      </p:sp>
+      <p:sp>
+        <p:nvSpPr>
+          <p:cNvPr id="257" name="Google Shape;257;p9"/>
+          <p:cNvSpPr txBox="1"/>
+          <p:nvPr/>
+        </p:nvSpPr>
+        <p:spPr>
+          <a:xfrm>
+            <a:off x="1104900" y="3394769"/>
+            <a:ext cx="4776900" cy="757200"/>
+          </a:xfrm>
+          <a:prstGeom prst="rect">
+            <a:avLst/>
+          </a:prstGeom>
+          <a:noFill/>
+          <a:ln>
+            <a:noFill/>
+          </a:ln>
+        </p:spPr>
+        <p:txBody>
+          <a:bodyPr anchorCtr="0" anchor="t" bIns="0" lIns="0" spcFirstLastPara="1" rIns="0" wrap="square" tIns="0">
+            <a:spAutoFit/>
+          </a:bodyPr>
+          <a:lstStyle/>
+          <a:p>
+            <a:pPr indent="0" lvl="0" marL="0" marR="0" rtl="0" algn="l">
+              <a:lnSpc>
+                <a:spcPct val="155000"/>
+              </a:lnSpc>
+              <a:spcBef>
+                <a:spcPts val="0"/>
+              </a:spcBef>
+              <a:spcAft>
+                <a:spcPts val="0"/>
+              </a:spcAft>
+              <a:buClr>
+                <a:srgbClr val="000000"/>
+              </a:buClr>
+              <a:buSzPts val="1200"/>
+              <a:buFont typeface="Arial"/>
+              <a:buNone/>
+            </a:pPr>
+            <a:r>
+              <a:rPr b="1" i="0" lang="en-US" sz="1200" u="none" cap="none" strike="noStrike">
+                <a:solidFill>
+                  <a:srgbClr val="FFFFFF"/>
+                </a:solidFill>
+                <a:latin typeface="Inter"/>
+                <a:ea typeface="Inter"/>
+                <a:cs typeface="Inter"/>
+                <a:sym typeface="Inter"/>
+              </a:rPr>
+              <a:t>The OLE Trigger:</a:t>
+            </a:r>
+            <a:r>
+              <a:rPr b="0" i="0" lang="en-US" sz="1200" u="none" cap="none" strike="noStrike">
+                <a:solidFill>
+                  <a:srgbClr val="CDD6F4"/>
+                </a:solidFill>
+                <a:latin typeface="Inter"/>
+                <a:ea typeface="Inter"/>
+                <a:cs typeface="Inter"/>
+                <a:sym typeface="Inter"/>
+              </a:rPr>
+              <a:t> If Excel blocks for over 30 seconds, Windows forces a modal alert: </a:t>
+            </a:r>
+            <a:r>
+              <a:rPr b="0" i="1" lang="en-US" sz="1200" u="none" cap="none" strike="noStrike">
+                <a:solidFill>
+                  <a:srgbClr val="CDD6F4"/>
+                </a:solidFill>
+                <a:latin typeface="Inter"/>
+                <a:ea typeface="Inter"/>
+                <a:cs typeface="Inter"/>
+                <a:sym typeface="Inter"/>
+              </a:rPr>
+              <a:t>"Microsoft Excel is waiting for another application…"</a:t>
+            </a:r>
+            <a:r>
+              <a:rPr b="0" i="0" lang="en-US" sz="1200" u="none" cap="none" strike="noStrike">
+                <a:solidFill>
+                  <a:srgbClr val="CDD6F4"/>
+                </a:solidFill>
+                <a:latin typeface="Inter"/>
+                <a:ea typeface="Inter"/>
+                <a:cs typeface="Inter"/>
+                <a:sym typeface="Inter"/>
+              </a:rPr>
+              <a:t>, freezing the unattended script.</a:t>
+            </a:r>
+            <a:endParaRPr b="0" i="0" sz="1400" u="none" cap="none" strike="noStrike">
+              <a:solidFill>
+                <a:srgbClr val="000000"/>
+              </a:solidFill>
+              <a:latin typeface="Arial"/>
+              <a:ea typeface="Arial"/>
+              <a:cs typeface="Arial"/>
+              <a:sym typeface="Arial"/>
+            </a:endParaRPr>
+          </a:p>
+        </p:txBody>
+      </p:sp>
+      <p:sp>
+        <p:nvSpPr>
+          <p:cNvPr id="258" name="Google Shape;258;p9"/>
+          <p:cNvSpPr txBox="1"/>
+          <p:nvPr/>
+        </p:nvSpPr>
+        <p:spPr>
+          <a:xfrm>
+            <a:off x="1104900" y="4217640"/>
+            <a:ext cx="4776900" cy="757200"/>
+          </a:xfrm>
+          <a:prstGeom prst="rect">
+            <a:avLst/>
+          </a:prstGeom>
+          <a:noFill/>
+          <a:ln>
+            <a:noFill/>
+          </a:ln>
+        </p:spPr>
+        <p:txBody>
+          <a:bodyPr anchorCtr="0" anchor="t" bIns="0" lIns="0" spcFirstLastPara="1" rIns="0" wrap="square" tIns="0">
+            <a:spAutoFit/>
+          </a:bodyPr>
+          <a:lstStyle/>
+          <a:p>
+            <a:pPr indent="0" lvl="0" marL="0" marR="0" rtl="0" algn="l">
+              <a:lnSpc>
+                <a:spcPct val="155000"/>
+              </a:lnSpc>
+              <a:spcBef>
+                <a:spcPts val="0"/>
+              </a:spcBef>
+              <a:spcAft>
+                <a:spcPts val="0"/>
+              </a:spcAft>
+              <a:buClr>
+                <a:srgbClr val="000000"/>
+              </a:buClr>
+              <a:buSzPts val="1200"/>
+              <a:buFont typeface="Arial"/>
+              <a:buNone/>
+            </a:pPr>
+            <a:r>
+              <a:rPr b="1" i="0" lang="en-US" sz="1200" u="none" cap="none" strike="noStrike">
+                <a:solidFill>
+                  <a:srgbClr val="FFFFFF"/>
+                </a:solidFill>
+                <a:latin typeface="Inter"/>
+                <a:ea typeface="Inter"/>
+                <a:cs typeface="Inter"/>
+                <a:sym typeface="Inter"/>
+              </a:rPr>
+              <a:t>Solution:</a:t>
+            </a:r>
+            <a:r>
+              <a:rPr b="0" i="0" lang="en-US" sz="1200" u="none" cap="none" strike="noStrike">
+                <a:solidFill>
+                  <a:srgbClr val="CDD6F4"/>
+                </a:solidFill>
+                <a:latin typeface="Inter"/>
+                <a:ea typeface="Inter"/>
+                <a:cs typeface="Inter"/>
+                <a:sym typeface="Inter"/>
+              </a:rPr>
+              <a:t> </a:t>
+            </a:r>
+            <a:r>
+              <a:rPr lang="en-US" sz="1200">
+                <a:solidFill>
+                  <a:srgbClr val="CDD6F4"/>
+                </a:solidFill>
+                <a:latin typeface="Inter"/>
+                <a:ea typeface="Inter"/>
+                <a:cs typeface="Inter"/>
+                <a:sym typeface="Inter"/>
+              </a:rPr>
+              <a:t>Implemented Windows API–based dialog management to identify and dismiss the Windows OLE dialog before continuing unattended SAP automation. </a:t>
             </a:r>
             <a:endParaRPr b="0" i="0" sz="1400" u="none" cap="none" strike="noStrike">
               <a:solidFill>
@@ -26780,7 +26900,7 @@
       </p:sp>
       <p:pic>
         <p:nvPicPr>
-          <p:cNvPr descr="image.png" id="256" name="Google Shape;256;p9"/>
+          <p:cNvPr descr="image.png" id="259" name="Google Shape;259;p9"/>
           <p:cNvPicPr preferRelativeResize="0"/>
           <p:nvPr/>
         </p:nvPicPr>
@@ -26807,7 +26927,7 @@
       </p:pic>
       <p:pic>
         <p:nvPicPr>
-          <p:cNvPr descr="image.png" id="257" name="Google Shape;257;p9"/>
+          <p:cNvPr descr="image.png" id="260" name="Google Shape;260;p9"/>
           <p:cNvPicPr preferRelativeResize="0"/>
           <p:nvPr/>
         </p:nvPicPr>
@@ -26834,7 +26954,7 @@
       </p:pic>
       <p:pic>
         <p:nvPicPr>
-          <p:cNvPr descr="image.png" id="258" name="Google Shape;258;p9"/>
+          <p:cNvPr descr="image.png" id="261" name="Google Shape;261;p9"/>
           <p:cNvPicPr preferRelativeResize="0"/>
           <p:nvPr/>
         </p:nvPicPr>
@@ -26859,36 +26979,9 @@
           </a:ln>
         </p:spPr>
       </p:pic>
-      <p:pic>
-        <p:nvPicPr>
-          <p:cNvPr descr="image.png" id="259" name="Google Shape;259;p9"/>
-          <p:cNvPicPr preferRelativeResize="0"/>
-          <p:nvPr/>
-        </p:nvPicPr>
-        <p:blipFill rotWithShape="1">
-          <a:blip r:embed="rId7">
-            <a:alphaModFix/>
-          </a:blip>
-          <a:srcRect b="0" l="0" r="0" t="0"/>
-          <a:stretch/>
-        </p:blipFill>
-        <p:spPr>
-          <a:xfrm>
-            <a:off x="771525" y="5370522"/>
-            <a:ext cx="190500" cy="180975"/>
-          </a:xfrm>
-          <a:prstGeom prst="rect">
-            <a:avLst/>
-          </a:prstGeom>
-          <a:noFill/>
-          <a:ln>
-            <a:noFill/>
-          </a:ln>
-        </p:spPr>
-      </p:pic>
       <p:sp>
         <p:nvSpPr>
-          <p:cNvPr id="260" name="Google Shape;260;p9"/>
+          <p:cNvPr id="262" name="Google Shape;262;p9"/>
           <p:cNvSpPr txBox="1"/>
           <p:nvPr/>
         </p:nvSpPr>
@@ -26954,7 +27047,7 @@
       </p:sp>
       <p:sp>
         <p:nvSpPr>
-          <p:cNvPr id="261" name="Google Shape;261;p9"/>
+          <p:cNvPr id="263" name="Google Shape;263;p9"/>
           <p:cNvSpPr/>
           <p:nvPr/>
         </p:nvSpPr>
@@ -27013,14 +27106,14 @@
       </p:sp>
       <p:sp>
         <p:nvSpPr>
-          <p:cNvPr id="262" name="Google Shape;262;p9"/>
+          <p:cNvPr id="264" name="Google Shape;264;p9"/>
           <p:cNvSpPr txBox="1"/>
           <p:nvPr/>
         </p:nvSpPr>
         <p:spPr>
           <a:xfrm>
             <a:off x="771525" y="6467475"/>
-            <a:ext cx="7029600" cy="138600"/>
+            <a:ext cx="7759500" cy="138600"/>
           </a:xfrm>
           <a:prstGeom prst="rect">
             <a:avLst/>
@@ -27063,7 +27156,7 @@
                 <a:cs typeface="Inter"/>
                 <a:sym typeface="Inter"/>
               </a:rPr>
-              <a:t>Implemented Windows API </a:t>
+              <a:t>Implemented Windows AP</a:t>
             </a:r>
             <a:r>
               <a:rPr lang="en-US" sz="900">
@@ -27075,7 +27168,31 @@
                 <a:cs typeface="Inter"/>
                 <a:sym typeface="Inter"/>
               </a:rPr>
-              <a:t>detection </a:t>
+              <a:t>I-based dialog</a:t>
+            </a:r>
+            <a:r>
+              <a:rPr b="0" i="0" lang="en-US" sz="900" u="none" cap="none" strike="noStrike">
+                <a:solidFill>
+                  <a:srgbClr val="4B5563"/>
+                </a:solidFill>
+                <a:latin typeface="Inter"/>
+                <a:ea typeface="Inter"/>
+                <a:cs typeface="Inter"/>
+                <a:sym typeface="Inter"/>
+              </a:rPr>
+              <a:t>I </a:t>
+            </a:r>
+            <a:r>
+              <a:rPr lang="en-US" sz="900">
+                <a:solidFill>
+                  <a:srgbClr val="4B5563"/>
+                </a:solidFill>
+                <a:latin typeface="Inter"/>
+                <a:ea typeface="Inter"/>
+                <a:cs typeface="Inter"/>
+                <a:sym typeface="Inter"/>
+              </a:rPr>
+              <a:t>management </a:t>
             </a:r>
             <a:r>
               <a:rPr b="0" i="0" lang="en-US" sz="900" u="none" cap="none" strike="noStrike">
@@ -27103,12 +27220,12 @@
       </p:sp>
       <p:pic>
         <p:nvPicPr>
-          <p:cNvPr id="263" name="Google Shape;263;p9"/>
+          <p:cNvPr id="265" name="Google Shape;265;p9"/>
           <p:cNvPicPr preferRelativeResize="0"/>
           <p:nvPr/>
         </p:nvPicPr>
         <p:blipFill rotWithShape="1">
-          <a:blip r:embed="rId8">
+          <a:blip r:embed="rId7">
             <a:alphaModFix/>
           </a:blip>
           <a:srcRect b="0" l="0" r="0" t="0"/>
@@ -27128,151 +27245,6 @@
           </a:ln>
         </p:spPr>
       </p:pic>
-      <p:pic>
-        <p:nvPicPr>
-          <p:cNvPr id="264" name="Google Shape;264;p9"/>
-          <p:cNvPicPr preferRelativeResize="0"/>
-          <p:nvPr/>
-        </p:nvPicPr>
-        <p:blipFill rotWithShape="1">
-          <a:blip r:embed="rId9">
-            <a:alphaModFix/>
-          </a:blip>
-          <a:srcRect b="0" l="0" r="0" t="0"/>
-          <a:stretch/>
-        </p:blipFill>
-        <p:spPr>
-          <a:xfrm>
-            <a:off x="6336613" y="4662651"/>
-            <a:ext cx="3114675" cy="1257300"/>
-          </a:xfrm>
-          <a:prstGeom prst="rect">
-            <a:avLst/>
-          </a:prstGeom>
-          <a:noFill/>
-          <a:ln>
-            <a:noFill/>
-          </a:ln>
-        </p:spPr>
-      </p:pic>
-      <p:sp>
-        <p:nvSpPr>
-          <p:cNvPr id="265" name="Google Shape;265;p9"/>
-          <p:cNvSpPr/>
-          <p:nvPr/>
-        </p:nvSpPr>
-        <p:spPr>
-          <a:xfrm>
-            <a:off x="9451300" y="3750751"/>
-            <a:ext cx="1947900" cy="1883400"/>
-          </a:xfrm>
-          <a:prstGeom prst="bentUpArrow">
-            <a:avLst>
-              <a:gd fmla="val 25000" name="adj1"/>
-              <a:gd fmla="val 25000" name="adj2"/>
-              <a:gd fmla="val 25000" name="adj3"/>
-            </a:avLst>
-          </a:prstGeom>
-          <a:solidFill>
-            <a:srgbClr val="FFFF00"/>
-          </a:solidFill>
-          <a:ln cap="flat" cmpd="sng" w="9525">
-            <a:solidFill>
-              <a:schemeClr val="dk2"/>
-            </a:solidFill>
-            <a:prstDash val="solid"/>
-            <a:round/>
-            <a:headEnd len="sm" w="sm" type="none"/>
-            <a:tailEnd len="sm" w="sm" type="none"/>
-          </a:ln>
-        </p:spPr>
-        <p:txBody>
-          <a:bodyPr anchorCtr="0" anchor="ctr" bIns="91425" lIns="91425" spcFirstLastPara="1" rIns="91425" wrap="square" tIns="91425">
-            <a:noAutofit/>
-          </a:bodyPr>
-          <a:lstStyle/>
-          <a:p>
-            <a:pPr indent="0" lvl="0" marL="0" marR="0" rtl="0" algn="ctr">
-              <a:lnSpc>
-                <a:spcPct val="100000"/>
-              </a:lnSpc>
-              <a:spcBef>
-                <a:spcPts val="0"/>
-              </a:spcBef>
-              <a:spcAft>
-                <a:spcPts val="0"/>
-              </a:spcAft>
-              <a:buClr>
-                <a:srgbClr val="000000"/>
-              </a:buClr>
-              <a:buSzPts val="1400"/>
-              <a:buFont typeface="Arial"/>
-              <a:buNone/>
-            </a:pPr>
-            <a:r>
-              <a:rPr b="0" i="0" lang="en-US" sz="1400" u="none" cap="none" strike="noStrike">
-                <a:solidFill>
-                  <a:schemeClr val="dk1"/>
-                </a:solidFill>
-                <a:latin typeface="Calibri"/>
-                <a:ea typeface="Calibri"/>
-                <a:cs typeface="Calibri"/>
-                <a:sym typeface="Calibri"/>
-              </a:rPr>
-              <a:t>“Auto-press”</a:t>
-            </a:r>
-            <a:endParaRPr b="0" i="0" sz="1400" u="none" cap="none" strike="noStrike">
-              <a:solidFill>
-                <a:schemeClr val="dk1"/>
-              </a:solidFill>
-              <a:latin typeface="Calibri"/>
-              <a:ea typeface="Calibri"/>
-              <a:cs typeface="Calibri"/>
-              <a:sym typeface="Calibri"/>
-            </a:endParaRPr>
-          </a:p>
-          <a:p>
-            <a:pPr indent="0" lvl="0" marL="0" marR="0" rtl="0" algn="ctr">
-              <a:lnSpc>
-                <a:spcPct val="100000"/>
-              </a:lnSpc>
-              <a:spcBef>
-                <a:spcPts val="0"/>
-              </a:spcBef>
-              <a:spcAft>
-                <a:spcPts val="0"/>
-              </a:spcAft>
-              <a:buClr>
-                <a:srgbClr val="000000"/>
-              </a:buClr>
-              <a:buSzPts val="1400"/>
-              <a:buFont typeface="Arial"/>
-              <a:buNone/>
-            </a:pPr>
-            <a:r>
-              <a:rPr b="0" i="0" lang="en-US" sz="1400" u="none" cap="none" strike="noStrike">
-                <a:solidFill>
-                  <a:schemeClr val="dk1"/>
-                </a:solidFill>
-                <a:latin typeface="Calibri"/>
-                <a:ea typeface="Calibri"/>
-                <a:cs typeface="Calibri"/>
-                <a:sym typeface="Calibri"/>
-              </a:rPr>
-              <a:t>when pop up</a:t>
-            </a:r>
-            <a:endParaRPr b="0" i="0" sz="1400" u="none" cap="none" strike="noStrike">
-              <a:solidFill>
-                <a:schemeClr val="dk1"/>
-              </a:solidFill>
-              <a:latin typeface="Calibri"/>
-              <a:ea typeface="Calibri"/>
-              <a:cs typeface="Calibri"/>
-              <a:sym typeface="Calibri"/>
-            </a:endParaRPr>
-          </a:p>
-        </p:txBody>
-      </p:sp>
     </p:spTree>
   </p:cSld>
   <p:clrMapOvr>
@@ -27282,6 +27254,285 @@
 </file>
 
 <file path=ppt/theme/theme1.xml><?xml version="1.0" encoding="utf-8"?>
+<a:theme xmlns:a="http://schemas.openxmlformats.org/drawingml/2006/main" xmlns:r="http://schemas.openxmlformats.org/officeDocument/2006/relationships">
+  <a:themeElements>
+    <a:clrScheme name="Default">
+      <a:dk1>
+        <a:srgbClr val="000000"/>
+      </a:dk1>
+      <a:lt1>
+        <a:srgbClr val="FFFFFF"/>
+      </a:lt1>
+      <a:dk2>
+        <a:srgbClr val="158158"/>
+      </a:dk2>
+      <a:lt2>
+        <a:srgbClr val="F3F3F3"/>
+      </a:lt2>
+      <a:accent1>
+        <a:srgbClr val="058DC7"/>
+      </a:accent1>
+      <a:accent2>
+        <a:srgbClr val="50B432"/>
+      </a:accent2>
+      <a:accent3>
+        <a:srgbClr val="ED561B"/>
+      </a:accent3>
+      <a:accent4>
+        <a:srgbClr val="EDEF00"/>
+      </a:accent4>
+      <a:accent5>
+        <a:srgbClr val="24CBE5"/>
+      </a:accent5>
+      <a:accent6>
+        <a:srgbClr val="64E572"/>
+      </a:accent6>
+      <a:hlink>
+        <a:srgbClr val="2200CC"/>
+      </a:hlink>
+      <a:folHlink>
+        <a:srgbClr val="551A8B"/>
+      </a:folHlink>
+    </a:clrScheme>
+    <a:fontScheme name="Office">
+      <a:majorFont>
+        <a:latin typeface="Arial"/>
+        <a:ea typeface=""/>
+        <a:cs typeface=""/>
+        <a:font script="Jpan" typeface="ＭＳ Ｐゴシック"/>
+        <a:font script="Hang" typeface="맑은 고딕"/>
+        <a:font script="Hans" typeface="宋体"/>
+        <a:font script="Hant" typeface="新細明體"/>
+        <a:font script="Arab" typeface="Times New Roman"/>
+        <a:font script="Hebr" typeface="Times New Roman"/>
+        <a:font script="Thai" typeface="Angsana New"/>
+        <a:font script="Ethi" typeface="Nyala"/>
+        <a:font script="Beng" typeface="Vrinda"/>
+        <a:font script="Gujr" typeface="Shruti"/>
+        <a:font script="Khmr" typeface="MoolBoran"/>
+        <a:font script="Knda" typeface="Tunga"/>
+        <a:font script="Guru" typeface="Raavi"/>
+        <a:font script="Cans" typeface="Euphemia"/>
+        <a:font script="Cher" typeface="Plantagenet Cherokee"/>
+        <a:font script="Yiii" typeface="Microsoft Yi Baiti"/>
+        <a:font script="Tibt" typeface="Microsoft Himalaya"/>
+        <a:font script="Thaa" typeface="MV Boli"/>
+        <a:font script="Deva" typeface="Mangal"/>
+        <a:font script="Telu" typeface="Gautami"/>
+        <a:font script="Taml" typeface="Latha"/>
+        <a:font script="Syrc" typeface="Estrangelo Edessa"/>
+        <a:font script="Orya" typeface="Kalinga"/>
+        <a:font script="Mlym" typeface="Kartika"/>
+        <a:font script="Laoo" typeface="DokChampa"/>
+        <a:font script="Sinh" typeface="Iskoola Pota"/>
+        <a:font script="Mong" typeface="Mongolian Baiti"/>
+        <a:font script="Viet" typeface="Times New Roman"/>
+        <a:font script="Uigh" typeface="Microsoft Uighur"/>
+        <a:font script="Geor" typeface="Sylfaen"/>
+      </a:majorFont>
+      <a:minorFont>
+        <a:latin typeface="Arial"/>
+        <a:ea typeface=""/>
+        <a:cs typeface=""/>
+        <a:font script="Jpan" typeface="ＭＳ Ｐゴシック"/>
+        <a:font script="Hang" typeface="맑은 고딕"/>
+        <a:font script="Hans" typeface="宋体"/>
+        <a:font script="Hant" typeface="新細明體"/>
+        <a:font script="Arab" typeface="Arial"/>
+        <a:font script="Hebr" typeface="Arial"/>
+        <a:font script="Thai" typeface="Cordia New"/>
+        <a:font script="Ethi" typeface="Nyala"/>
+        <a:font script="Beng" typeface="Vrinda"/>
+        <a:font script="Gujr" typeface="Shruti"/>
+        <a:font script="Khmr" typeface="DaunPenh"/>
+        <a:font script="Knda" typeface="Tunga"/>
+        <a:font script="Guru" typeface="Raavi"/>
+        <a:font script="Cans" typeface="Euphemia"/>
+        <a:font script="Cher" typeface="Plantagenet Cherokee"/>
+        <a:font script="Yiii" typeface="Microsoft Yi Baiti"/>
+        <a:font script="Tibt" typeface="Microsoft Himalaya"/>
+        <a:font script="Thaa" typeface="MV Boli"/>
+        <a:font script="Deva" typeface="Mangal"/>
+        <a:font script="Telu" typeface="Gautami"/>
+        <a:font script="Taml" typeface="Latha"/>
+        <a:font script="Syrc" typeface="Estrangelo Edessa"/>
+        <a:font script="Orya" typeface="Kalinga"/>
+        <a:font script="Mlym" typeface="Kartika"/>
+        <a:font script="Laoo" typeface="DokChampa"/>
+        <a:font script="Sinh" typeface="Iskoola Pota"/>
+        <a:font script="Mong" typeface="Mongolian Baiti"/>
+        <a:font script="Viet" typeface="Arial"/>
+        <a:font script="Uigh" typeface="Microsoft Uighur"/>
+        <a:font script="Geor" typeface="Sylfaen"/>
+      </a:minorFont>
+    </a:fontScheme>
+    <a:fmtScheme name="Office">
+      <a:fillStyleLst>
+        <a:solidFill>
+          <a:schemeClr val="phClr"/>
+        </a:solidFill>
+        <a:gradFill rotWithShape="1">
+          <a:gsLst>
+            <a:gs pos="0">
+              <a:schemeClr val="phClr">
+                <a:tint val="50000"/>
+                <a:satMod val="300000"/>
+              </a:schemeClr>
+            </a:gs>
+            <a:gs pos="35000">
+              <a:schemeClr val="phClr">
+                <a:tint val="37000"/>
+                <a:satMod val="300000"/>
+              </a:schemeClr>
+            </a:gs>
+            <a:gs pos="100000">
+              <a:schemeClr val="phClr">
+                <a:tint val="15000"/>
+                <a:satMod val="350000"/>
+              </a:schemeClr>
+            </a:gs>
+          </a:gsLst>
+          <a:lin ang="16200000" scaled="1"/>
+        </a:gradFill>
+        <a:gradFill rotWithShape="1">
+          <a:gsLst>
+            <a:gs pos="0">
+              <a:schemeClr val="phClr">
+                <a:tint val="100000"/>
+                <a:shade val="100000"/>
+                <a:satMod val="130000"/>
+              </a:schemeClr>
+            </a:gs>
+            <a:gs pos="100000">
+              <a:schemeClr val="phClr">
+                <a:tint val="50000"/>
+                <a:shade val="100000"/>
+                <a:satMod val="350000"/>
+              </a:schemeClr>
+            </a:gs>
+          </a:gsLst>
+          <a:lin ang="16200000" scaled="0"/>
+        </a:gradFill>
+      </a:fillStyleLst>
+      <a:lnStyleLst>
+        <a:ln w="9525" cap="flat" cmpd="sng" algn="ctr">
+          <a:solidFill>
+            <a:schemeClr val="phClr">
+              <a:shade val="95000"/>
+              <a:satMod val="105000"/>
+            </a:schemeClr>
+          </a:solidFill>
+          <a:prstDash val="solid"/>
+        </a:ln>
+        <a:ln w="25400" cap="flat" cmpd="sng" algn="ctr">
+          <a:solidFill>
+            <a:schemeClr val="phClr"/>
+          </a:solidFill>
+          <a:prstDash val="solid"/>
+        </a:ln>
+        <a:ln w="38100" cap="flat" cmpd="sng" algn="ctr">
+          <a:solidFill>
+            <a:schemeClr val="phClr"/>
+          </a:solidFill>
+          <a:prstDash val="solid"/>
+        </a:ln>
+      </a:lnStyleLst>
+      <a:effectStyleLst>
+        <a:effectStyle>
+          <a:effectLst>
+            <a:outerShdw blurRad="40000" dist="20000" dir="5400000" rotWithShape="0">
+              <a:srgbClr val="000000">
+                <a:alpha val="38000"/>
+              </a:srgbClr>
+            </a:outerShdw>
+          </a:effectLst>
+        </a:effectStyle>
+        <a:effectStyle>
+          <a:effectLst>
+            <a:outerShdw blurRad="40000" dist="23000" dir="5400000" rotWithShape="0">
+              <a:srgbClr val="000000">
+                <a:alpha val="35000"/>
+              </a:srgbClr>
+            </a:outerShdw>
+          </a:effectLst>
+        </a:effectStyle>
+        <a:effectStyle>
+          <a:effectLst>
+            <a:outerShdw blurRad="40000" dist="23000" dir="5400000" rotWithShape="0">
+              <a:srgbClr val="000000">
+                <a:alpha val="35000"/>
+              </a:srgbClr>
+            </a:outerShdw>
+          </a:effectLst>
+          <a:scene3d>
+            <a:camera prst="orthographicFront">
+              <a:rot lat="0" lon="0" rev="0"/>
+            </a:camera>
+            <a:lightRig rig="threePt" dir="t">
+              <a:rot lat="0" lon="0" rev="1200000"/>
+            </a:lightRig>
+          </a:scene3d>
+          <a:sp3d>
+            <a:bevelT w="63500" h="25400"/>
+          </a:sp3d>
+        </a:effectStyle>
+      </a:effectStyleLst>
+      <a:bgFillStyleLst>
+        <a:solidFill>
+          <a:schemeClr val="phClr"/>
+        </a:solidFill>
+        <a:gradFill rotWithShape="1">
+          <a:gsLst>
+            <a:gs pos="0">
+              <a:schemeClr val="phClr">
+                <a:tint val="40000"/>
+                <a:satMod val="350000"/>
+              </a:schemeClr>
+            </a:gs>
+            <a:gs pos="40000">
+              <a:schemeClr val="phClr">
+                <a:tint val="45000"/>
+                <a:shade val="99000"/>
+                <a:satMod val="350000"/>
+              </a:schemeClr>
+            </a:gs>
+            <a:gs pos="100000">
+              <a:schemeClr val="phClr">
+                <a:shade val="20000"/>
+                <a:satMod val="255000"/>
+              </a:schemeClr>
+            </a:gs>
+          </a:gsLst>
+          <a:path path="circle">
+            <a:fillToRect l="50000" t="-80000" r="50000" b="180000"/>
+          </a:path>
+        </a:gradFill>
+        <a:gradFill rotWithShape="1">
+          <a:gsLst>
+            <a:gs pos="0">
+              <a:schemeClr val="phClr">
+                <a:tint val="80000"/>
+                <a:satMod val="300000"/>
+              </a:schemeClr>
+            </a:gs>
+            <a:gs pos="100000">
+              <a:schemeClr val="phClr">
+                <a:shade val="30000"/>
+                <a:satMod val="200000"/>
+              </a:schemeClr>
+            </a:gs>
+          </a:gsLst>
+          <a:path path="circle">
+            <a:fillToRect l="50000" t="50000" r="50000" b="50000"/>
+          </a:path>
+        </a:gradFill>
+      </a:bgFillStyleLst>
+    </a:fmtScheme>
+  </a:themeElements>
+</a:theme>
+</file>
+
+<file path=ppt/theme/theme2.xml><?xml version="1.0" encoding="utf-8"?>
 <a:theme xmlns:a="http://schemas.openxmlformats.org/drawingml/2006/main" xmlns:r="http://schemas.openxmlformats.org/officeDocument/2006/relationships" name="Office Theme">
   <a:themeElements>
     <a:clrScheme name="Office">
@@ -27558,283 +27809,4 @@
     </a:fmtScheme>
   </a:themeElements>
 </a:theme>
-</file>
-
-<file path=ppt/theme/theme2.xml><?xml version="1.0" encoding="utf-8"?>
-<a:theme xmlns:a="http://schemas.openxmlformats.org/drawingml/2006/main" xmlns:r="http://schemas.openxmlformats.org/officeDocument/2006/relationships">
-  <a:themeElements>
-    <a:clrScheme name="Default">
-      <a:dk1>
-        <a:srgbClr val="000000"/>
-      </a:dk1>
-      <a:lt1>
-        <a:srgbClr val="FFFFFF"/>
-      </a:lt1>
-      <a:dk2>
-        <a:srgbClr val="158158"/>
-      </a:dk2>
-      <a:lt2>
-        <a:srgbClr val="F3F3F3"/>
-      </a:lt2>
-      <a:accent1>
-        <a:srgbClr val="058DC7"/>
-      </a:accent1>
-      <a:accent2>
-        <a:srgbClr val="50B432"/>
-      </a:accent2>
-      <a:accent3>
-        <a:srgbClr val="ED561B"/>
-      </a:accent3>
-      <a:accent4>
-        <a:srgbClr val="EDEF00"/>
-      </a:accent4>
-      <a:accent5>
-        <a:srgbClr val="24CBE5"/>
-      </a:accent5>
-      <a:accent6>
-        <a:srgbClr val="64E572"/>
-      </a:accent6>
-      <a:hlink>
-        <a:srgbClr val="2200CC"/>
-      </a:hlink>
-      <a:folHlink>
-        <a:srgbClr val="551A8B"/>
-      </a:folHlink>
-    </a:clrScheme>
-    <a:fontScheme name="Office">
-      <a:majorFont>
-        <a:latin typeface="Arial"/>
-        <a:ea typeface=""/>
-        <a:cs typeface=""/>
-        <a:font script="Jpan" typeface="ＭＳ Ｐゴシック"/>
-        <a:font script="Hang" typeface="맑은 고딕"/>
-        <a:font script="Hans" typeface="宋体"/>
-        <a:font script="Hant" typeface="新細明體"/>
-        <a:font script="Arab" typeface="Times New Roman"/>
-        <a:font script="Hebr" typeface="Times New Roman"/>
-        <a:font script="Thai" typeface="Angsana New"/>
-        <a:font script="Ethi" typeface="Nyala"/>
-        <a:font script="Beng" typeface="Vrinda"/>
-        <a:font script="Gujr" typeface="Shruti"/>
-        <a:font script="Khmr" typeface="MoolBoran"/>
-        <a:font script="Knda" typeface="Tunga"/>
-        <a:font script="Guru" typeface="Raavi"/>
-        <a:font script="Cans" typeface="Euphemia"/>
-        <a:font script="Cher" typeface="Plantagenet Cherokee"/>
-        <a:font script="Yiii" typeface="Microsoft Yi Baiti"/>
-        <a:font script="Tibt" typeface="Microsoft Himalaya"/>
-        <a:font script="Thaa" typeface="MV Boli"/>
-        <a:font script="Deva" typeface="Mangal"/>
-        <a:font script="Telu" typeface="Gautami"/>
-        <a:font script="Taml" typeface="Latha"/>
-        <a:font script="Syrc" typeface="Estrangelo Edessa"/>
-        <a:font script="Orya" typeface="Kalinga"/>
-        <a:font script="Mlym" typeface="Kartika"/>
-        <a:font script="Laoo" typeface="DokChampa"/>
-        <a:font script="Sinh" typeface="Iskoola Pota"/>
-        <a:font script="Mong" typeface="Mongolian Baiti"/>
-        <a:font script="Viet" typeface="Times New Roman"/>
-        <a:font script="Uigh" typeface="Microsoft Uighur"/>
-        <a:font script="Geor" typeface="Sylfaen"/>
-      </a:majorFont>
-      <a:minorFont>
-        <a:latin typeface="Arial"/>
-        <a:ea typeface=""/>
-        <a:cs typeface=""/>
-        <a:font script="Jpan" typeface="ＭＳ Ｐゴシック"/>
-        <a:font script="Hang" typeface="맑은 고딕"/>
-        <a:font script="Hans" typeface="宋体"/>
-        <a:font script="Hant" typeface="新細明體"/>
-        <a:font script="Arab" typeface="Arial"/>
-        <a:font script="Hebr" typeface="Arial"/>
-        <a:font script="Thai" typeface="Cordia New"/>
-        <a:font script="Ethi" typeface="Nyala"/>
-        <a:font script="Beng" typeface="Vrinda"/>
-        <a:font script="Gujr" typeface="Shruti"/>
-        <a:font script="Khmr" typeface="DaunPenh"/>
-        <a:font script="Knda" typeface="Tunga"/>
-        <a:font script="Guru" typeface="Raavi"/>
-        <a:font script="Cans" typeface="Euphemia"/>
-        <a:font script="Cher" typeface="Plantagenet Cherokee"/>
-        <a:font script="Yiii" typeface="Microsoft Yi Baiti"/>
-        <a:font script="Tibt" typeface="Microsoft Himalaya"/>
-        <a:font script="Thaa" typeface="MV Boli"/>
-        <a:font script="Deva" typeface="Mangal"/>
-        <a:font script="Telu" typeface="Gautami"/>
-        <a:font script="Taml" typeface="Latha"/>
-        <a:font script="Syrc" typeface="Estrangelo Edessa"/>
-        <a:font script="Orya" typeface="Kalinga"/>
-        <a:font script="Mlym" typeface="Kartika"/>
-        <a:font script="Laoo" typeface="DokChampa"/>
-        <a:font script="Sinh" typeface="Iskoola Pota"/>
-        <a:font script="Mong" typeface="Mongolian Baiti"/>
-        <a:font script="Viet" typeface="Arial"/>
-        <a:font script="Uigh" typeface="Microsoft Uighur"/>
-        <a:font script="Geor" typeface="Sylfaen"/>
-      </a:minorFont>
-    </a:fontScheme>
-    <a:fmtScheme name="Office">
-      <a:fillStyleLst>
-        <a:solidFill>
-          <a:schemeClr val="phClr"/>
-        </a:solidFill>
-        <a:gradFill rotWithShape="1">
-          <a:gsLst>
-            <a:gs pos="0">
-              <a:schemeClr val="phClr">
-                <a:tint val="50000"/>
-                <a:satMod val="300000"/>
-              </a:schemeClr>
-            </a:gs>
-            <a:gs pos="35000">
-              <a:schemeClr val="phClr">
-                <a:tint val="37000"/>
-                <a:satMod val="300000"/>
-              </a:schemeClr>
-            </a:gs>
-            <a:gs pos="100000">
-              <a:schemeClr val="phClr">
-                <a:tint val="15000"/>
-                <a:satMod val="350000"/>
-              </a:schemeClr>
-            </a:gs>
-          </a:gsLst>
-          <a:lin ang="16200000" scaled="1"/>
-        </a:gradFill>
-        <a:gradFill rotWithShape="1">
-          <a:gsLst>
-            <a:gs pos="0">
-              <a:schemeClr val="phClr">
-                <a:tint val="100000"/>
-                <a:shade val="100000"/>
-                <a:satMod val="130000"/>
-              </a:schemeClr>
-            </a:gs>
-            <a:gs pos="100000">
-              <a:schemeClr val="phClr">
-                <a:tint val="50000"/>
-                <a:shade val="100000"/>
-                <a:satMod val="350000"/>
-              </a:schemeClr>
-            </a:gs>
-          </a:gsLst>
-          <a:lin ang="16200000" scaled="0"/>
-        </a:gradFill>
-      </a:fillStyleLst>
-      <a:lnStyleLst>
-        <a:ln w="9525" cap="flat" cmpd="sng" algn="ctr">
-          <a:solidFill>
-            <a:schemeClr val="phClr">
-              <a:shade val="95000"/>
-              <a:satMod val="105000"/>
-            </a:schemeClr>
-          </a:solidFill>
-          <a:prstDash val="solid"/>
-        </a:ln>
-        <a:ln w="25400" cap="flat" cmpd="sng" algn="ctr">
-          <a:solidFill>
-            <a:schemeClr val="phClr"/>
-          </a:solidFill>
-          <a:prstDash val="solid"/>
-        </a:ln>
-        <a:ln w="38100" cap="flat" cmpd="sng" algn="ctr">
-          <a:solidFill>
-            <a:schemeClr val="phClr"/>
-          </a:solidFill>
-          <a:prstDash val="solid"/>
-        </a:ln>
-      </a:lnStyleLst>
-      <a:effectStyleLst>
-        <a:effectStyle>
-          <a:effectLst>
-            <a:outerShdw blurRad="40000" dist="20000" dir="5400000" rotWithShape="0">
-              <a:srgbClr val="000000">
-                <a:alpha val="38000"/>
-              </a:srgbClr>
-            </a:outerShdw>
-          </a:effectLst>
-        </a:effectStyle>
-        <a:effectStyle>
-          <a:effectLst>
-            <a:outerShdw blurRad="40000" dist="23000" dir="5400000" rotWithShape="0">
-              <a:srgbClr val="000000">
-                <a:alpha val="35000"/>
-              </a:srgbClr>
-            </a:outerShdw>
-          </a:effectLst>
-        </a:effectStyle>
-        <a:effectStyle>
-          <a:effectLst>
-            <a:outerShdw blurRad="40000" dist="23000" dir="5400000" rotWithShape="0">
-              <a:srgbClr val="000000">
-                <a:alpha val="35000"/>
-              </a:srgbClr>
-            </a:outerShdw>
-          </a:effectLst>
-          <a:scene3d>
-            <a:camera prst="orthographicFront">
-              <a:rot lat="0" lon="0" rev="0"/>
-            </a:camera>
-            <a:lightRig rig="threePt" dir="t">
-              <a:rot lat="0" lon="0" rev="1200000"/>
-            </a:lightRig>
-          </a:scene3d>
-          <a:sp3d>
-            <a:bevelT w="63500" h="25400"/>
-          </a:sp3d>
-        </a:effectStyle>
-      </a:effectStyleLst>
-      <a:bgFillStyleLst>
-        <a:solidFill>
-          <a:schemeClr val="phClr"/>
-        </a:solidFill>
-        <a:gradFill rotWithShape="1">
-          <a:gsLst>
-            <a:gs pos="0">
-              <a:schemeClr val="phClr">
-                <a:tint val="40000"/>
-                <a:satMod val="350000"/>
-              </a:schemeClr>
-            </a:gs>
-            <a:gs pos="40000">
-              <a:schemeClr val="phClr">
-                <a:tint val="45000"/>
-                <a:shade val="99000"/>
-                <a:satMod val="350000"/>
-              </a:schemeClr>
-            </a:gs>
-            <a:gs pos="100000">
-              <a:schemeClr val="phClr">
-                <a:shade val="20000"/>
-                <a:satMod val="255000"/>
-              </a:schemeClr>
-            </a:gs>
-          </a:gsLst>
-          <a:path path="circle">
-            <a:fillToRect l="50000" t="-80000" r="50000" b="180000"/>
-          </a:path>
-        </a:gradFill>
-        <a:gradFill rotWithShape="1">
-          <a:gsLst>
-            <a:gs pos="0">
-              <a:schemeClr val="phClr">
-                <a:tint val="80000"/>
-                <a:satMod val="300000"/>
-              </a:schemeClr>
-            </a:gs>
-            <a:gs pos="100000">
-              <a:schemeClr val="phClr">
-                <a:shade val="30000"/>
-                <a:satMod val="200000"/>
-              </a:schemeClr>
-            </a:gs>
-          </a:gsLst>
-          <a:path path="circle">
-            <a:fillToRect l="50000" t="50000" r="50000" b="50000"/>
-          </a:path>
-        </a:gradFill>
-      </a:bgFillStyleLst>
-    </a:fmtScheme>
-  </a:themeElements>
-</a:theme>
 </file>
</xml_diff>

<commit_message>
upload presentation slide final
</commit_message>
<xml_diff>
--- a/vba-sap-document-batch-export/Resources/Project_presentation_slides.pptx
+++ b/vba-sap-document-batch-export/Resources/Project_presentation_slides.pptx
@@ -306,7 +306,7 @@
       </p15:sldGuideLst>
     </p:ext>
     <p:ext uri="GoogleSlidesCustomDataVersion2">
-      <go:slidesCustomData xmlns:go="http://customooxmlschemas.google.com/" r:id="rId40" roundtripDataSignature="AMtx7mgTbYRRx7TIxzsyNItfu70FqUx9Pg=="/>
+      <go:slidesCustomData xmlns:go="http://customooxmlschemas.google.com/" r:id="rId40" roundtripDataSignature="AMtx7mhyiUhKV9Ty1C/g/PphhfG7cEadRQ=="/>
     </p:ext>
   </p:extLst>
 </p:presentation>
@@ -1229,7 +1229,7 @@
   <p:cSld>
     <p:spTree>
       <p:nvGrpSpPr>
-        <p:cNvPr id="293" name="Shape 293"/>
+        <p:cNvPr id="294" name="Shape 294"/>
         <p:cNvGrpSpPr/>
         <p:nvPr/>
       </p:nvGrpSpPr>
@@ -1243,7 +1243,7 @@
       </p:grpSpPr>
       <p:sp>
         <p:nvSpPr>
-          <p:cNvPr id="294" name="Google Shape;294;p12:notes"/>
+          <p:cNvPr id="295" name="Google Shape;295;p12:notes"/>
           <p:cNvSpPr txBox="1"/>
           <p:nvPr>
             <p:ph idx="1" type="body"/>
@@ -1290,7 +1290,7 @@
       </p:sp>
       <p:sp>
         <p:nvSpPr>
-          <p:cNvPr id="295" name="Google Shape;295;p12:notes"/>
+          <p:cNvPr id="296" name="Google Shape;296;p12:notes"/>
           <p:cNvSpPr/>
           <p:nvPr>
             <p:ph idx="2" type="sldImg"/>
@@ -1346,7 +1346,7 @@
   <p:cSld>
     <p:spTree>
       <p:nvGrpSpPr>
-        <p:cNvPr id="314" name="Shape 314"/>
+        <p:cNvPr id="315" name="Shape 315"/>
         <p:cNvGrpSpPr/>
         <p:nvPr/>
       </p:nvGrpSpPr>
@@ -1360,7 +1360,7 @@
       </p:grpSpPr>
       <p:sp>
         <p:nvSpPr>
-          <p:cNvPr id="315" name="Google Shape;315;p13:notes"/>
+          <p:cNvPr id="316" name="Google Shape;316;p13:notes"/>
           <p:cNvSpPr txBox="1"/>
           <p:nvPr>
             <p:ph idx="1" type="body"/>
@@ -1407,7 +1407,7 @@
       </p:sp>
       <p:sp>
         <p:nvSpPr>
-          <p:cNvPr id="316" name="Google Shape;316;p13:notes"/>
+          <p:cNvPr id="317" name="Google Shape;317;p13:notes"/>
           <p:cNvSpPr/>
           <p:nvPr>
             <p:ph idx="2" type="sldImg"/>
@@ -16702,7 +16702,7 @@
         <p:spPr>
           <a:xfrm>
             <a:off x="2143125" y="4402335"/>
-            <a:ext cx="8239125" cy="501848"/>
+            <a:ext cx="8239200" cy="1108800"/>
           </a:xfrm>
           <a:prstGeom prst="rect">
             <a:avLst/>
@@ -16759,14 +16759,66 @@
               </a:rPr>
               <a:t> Organizing codebase structures into isolated logical modules for easy maintenance, extension, and deployment.</a:t>
             </a:r>
-            <a:endParaRPr b="0" i="0" sz="1400" u="none" cap="none" strike="noStrike">
+            <a:endParaRPr b="0" i="0" sz="1275" u="none" cap="none" strike="noStrike">
               <a:solidFill>
-                <a:srgbClr val="000000"/>
+                <a:srgbClr val="CDD6F4"/>
               </a:solidFill>
-              <a:latin typeface="Arial"/>
-              <a:ea typeface="Arial"/>
-              <a:cs typeface="Arial"/>
-              <a:sym typeface="Arial"/>
+              <a:latin typeface="Inter"/>
+              <a:ea typeface="Inter"/>
+              <a:cs typeface="Inter"/>
+              <a:sym typeface="Inter"/>
+            </a:endParaRPr>
+          </a:p>
+          <a:p>
+            <a:pPr indent="0" lvl="0" marL="0" marR="0" rtl="0" algn="l">
+              <a:lnSpc>
+                <a:spcPct val="154980"/>
+              </a:lnSpc>
+              <a:spcBef>
+                <a:spcPts val="0"/>
+              </a:spcBef>
+              <a:spcAft>
+                <a:spcPts val="0"/>
+              </a:spcAft>
+              <a:buClr>
+                <a:srgbClr val="000000"/>
+              </a:buClr>
+              <a:buSzPts val="1275"/>
+              <a:buFont typeface="Arial"/>
+              <a:buNone/>
+            </a:pPr>
+            <a:r>
+              <a:rPr b="1" lang="en-US" sz="1275">
+                <a:solidFill>
+                  <a:schemeClr val="lt1"/>
+                </a:solidFill>
+                <a:latin typeface="Inter"/>
+                <a:ea typeface="Inter"/>
+                <a:cs typeface="Inter"/>
+                <a:sym typeface="Inter"/>
+              </a:rPr>
+              <a:t>Key Takeaway: </a:t>
+            </a:r>
+            <a:r>
+              <a:rPr lang="en-US" sz="1275">
+                <a:solidFill>
+                  <a:srgbClr val="CDD6F4"/>
+                </a:solidFill>
+                <a:latin typeface="Inter"/>
+                <a:ea typeface="Inter"/>
+                <a:cs typeface="Inter"/>
+                <a:sym typeface="Inter"/>
+              </a:rPr>
+              <a:t>Demonstrating how software engineering and process automation can eliminate repetitive work in enterprise operations without requiring modifications to existing ERP systems. </a:t>
+            </a:r>
+            <a:endParaRPr sz="1275">
+              <a:solidFill>
+                <a:srgbClr val="CDD6F4"/>
+              </a:solidFill>
+              <a:latin typeface="Inter"/>
+              <a:ea typeface="Inter"/>
+              <a:cs typeface="Inter"/>
+              <a:sym typeface="Inter"/>
             </a:endParaRPr>
           </a:p>
         </p:txBody>
@@ -17004,6 +17056,33 @@
           </a:p>
         </p:txBody>
       </p:sp>
+      <p:pic>
+        <p:nvPicPr>
+          <p:cNvPr descr="image.png" id="293" name="Google Shape;293;p11"/>
+          <p:cNvPicPr preferRelativeResize="0"/>
+          <p:nvPr/>
+        </p:nvPicPr>
+        <p:blipFill rotWithShape="1">
+          <a:blip r:embed="rId4">
+            <a:alphaModFix/>
+          </a:blip>
+          <a:srcRect b="0" l="0" r="0" t="0"/>
+          <a:stretch/>
+        </p:blipFill>
+        <p:spPr>
+          <a:xfrm>
+            <a:off x="1809750" y="5070873"/>
+            <a:ext cx="219075" cy="200025"/>
+          </a:xfrm>
+          <a:prstGeom prst="rect">
+            <a:avLst/>
+          </a:prstGeom>
+          <a:noFill/>
+          <a:ln>
+            <a:noFill/>
+          </a:ln>
+        </p:spPr>
+      </p:pic>
     </p:spTree>
   </p:cSld>
   <p:clrMapOvr>
@@ -17024,7 +17103,7 @@
     </p:bg>
     <p:spTree>
       <p:nvGrpSpPr>
-        <p:cNvPr id="296" name="Shape 296"/>
+        <p:cNvPr id="297" name="Shape 297"/>
         <p:cNvGrpSpPr/>
         <p:nvPr/>
       </p:nvGrpSpPr>
@@ -17038,7 +17117,7 @@
       </p:grpSpPr>
       <p:pic>
         <p:nvPicPr>
-          <p:cNvPr descr="image.png" id="297" name="Google Shape;297;p12"/>
+          <p:cNvPr descr="image.png" id="298" name="Google Shape;298;p12"/>
           <p:cNvPicPr preferRelativeResize="0"/>
           <p:nvPr/>
         </p:nvPicPr>
@@ -17065,7 +17144,7 @@
       </p:pic>
       <p:pic>
         <p:nvPicPr>
-          <p:cNvPr descr="image.png" id="298" name="Google Shape;298;p12"/>
+          <p:cNvPr descr="image.png" id="299" name="Google Shape;299;p12"/>
           <p:cNvPicPr preferRelativeResize="0"/>
           <p:nvPr/>
         </p:nvPicPr>
@@ -17092,7 +17171,7 @@
       </p:pic>
       <p:pic>
         <p:nvPicPr>
-          <p:cNvPr descr="image.png" id="299" name="Google Shape;299;p12"/>
+          <p:cNvPr descr="image.png" id="300" name="Google Shape;300;p12"/>
           <p:cNvPicPr preferRelativeResize="0"/>
           <p:nvPr/>
         </p:nvPicPr>
@@ -17119,7 +17198,7 @@
       </p:pic>
       <p:sp>
         <p:nvSpPr>
-          <p:cNvPr id="300" name="Google Shape;300;p12"/>
+          <p:cNvPr id="301" name="Google Shape;301;p12"/>
           <p:cNvSpPr txBox="1"/>
           <p:nvPr/>
         </p:nvSpPr>
@@ -17170,72 +17249,6 @@
                 <a:sym typeface="Montserrat SemiBold"/>
               </a:rPr>
               <a:t>System Scaling</a:t>
-            </a:r>
-            <a:endParaRPr b="0" i="0" sz="1400" u="none" cap="none" strike="noStrike">
-              <a:solidFill>
-                <a:srgbClr val="000000"/>
-              </a:solidFill>
-              <a:latin typeface="Arial"/>
-              <a:ea typeface="Arial"/>
-              <a:cs typeface="Arial"/>
-              <a:sym typeface="Arial"/>
-            </a:endParaRPr>
-          </a:p>
-        </p:txBody>
-      </p:sp>
-      <p:sp>
-        <p:nvSpPr>
-          <p:cNvPr id="301" name="Google Shape;301;p12"/>
-          <p:cNvSpPr txBox="1"/>
-          <p:nvPr/>
-        </p:nvSpPr>
-        <p:spPr>
-          <a:xfrm>
-            <a:off x="1066800" y="3044576"/>
-            <a:ext cx="4519612" cy="752772"/>
-          </a:xfrm>
-          <a:prstGeom prst="rect">
-            <a:avLst/>
-          </a:prstGeom>
-          <a:noFill/>
-          <a:ln>
-            <a:noFill/>
-          </a:ln>
-        </p:spPr>
-        <p:txBody>
-          <a:bodyPr anchorCtr="0" anchor="t" bIns="0" lIns="0" spcFirstLastPara="1" rIns="0" wrap="square" tIns="0">
-            <a:spAutoFit/>
-          </a:bodyPr>
-          <a:lstStyle/>
-          <a:p>
-            <a:pPr indent="0" lvl="0" marL="0" marR="0" rtl="0" algn="l">
-              <a:lnSpc>
-                <a:spcPct val="154980"/>
-              </a:lnSpc>
-              <a:spcBef>
-                <a:spcPts val="0"/>
-              </a:spcBef>
-              <a:spcAft>
-                <a:spcPts val="0"/>
-              </a:spcAft>
-              <a:buClr>
-                <a:srgbClr val="000000"/>
-              </a:buClr>
-              <a:buSzPts val="1275"/>
-              <a:buFont typeface="Arial"/>
-              <a:buNone/>
-            </a:pPr>
-            <a:r>
-              <a:rPr b="0" i="0" lang="en-US" sz="1275" u="none" cap="none" strike="noStrike">
-                <a:solidFill>
-                  <a:srgbClr val="CDD6F4"/>
-                </a:solidFill>
-                <a:latin typeface="Inter"/>
-                <a:ea typeface="Inter"/>
-                <a:cs typeface="Inter"/>
-                <a:sym typeface="Inter"/>
-              </a:rPr>
-              <a:t>The code architecture is modularly decoupled, meaning it can be expanded to automate other core business procedures:</a:t>
             </a:r>
             <a:endParaRPr b="0" i="0" sz="1400" u="none" cap="none" strike="noStrike">
               <a:solidFill>
@@ -17257,8 +17270,8 @@
         </p:nvSpPr>
         <p:spPr>
           <a:xfrm>
-            <a:off x="6605587" y="2673101"/>
-            <a:ext cx="4745593" cy="276225"/>
+            <a:off x="1066800" y="3044576"/>
+            <a:ext cx="4519612" cy="752772"/>
           </a:xfrm>
           <a:prstGeom prst="rect">
             <a:avLst/>
@@ -17276,32 +17289,32 @@
           <a:p>
             <a:pPr indent="0" lvl="0" marL="0" marR="0" rtl="0" algn="l">
               <a:lnSpc>
-                <a:spcPct val="100000"/>
-              </a:lnSpc>
-              <a:spcBef>
-                <a:spcPts val="0"/>
-              </a:spcBef>
-              <a:spcAft>
-                <a:spcPts val="0"/>
-              </a:spcAft>
-              <a:buClr>
-                <a:srgbClr val="000000"/>
-              </a:buClr>
-              <a:buSzPts val="1800"/>
+                <a:spcPct val="154980"/>
+              </a:lnSpc>
+              <a:spcBef>
+                <a:spcPts val="0"/>
+              </a:spcBef>
+              <a:spcAft>
+                <a:spcPts val="0"/>
+              </a:spcAft>
+              <a:buClr>
+                <a:srgbClr val="000000"/>
+              </a:buClr>
+              <a:buSzPts val="1275"/>
               <a:buFont typeface="Arial"/>
               <a:buNone/>
             </a:pPr>
             <a:r>
-              <a:rPr b="0" i="0" lang="en-US" sz="1800" u="none" cap="none" strike="noStrike">
-                <a:solidFill>
-                  <a:srgbClr val="64FFDA"/>
-                </a:solidFill>
-                <a:latin typeface="Montserrat SemiBold"/>
-                <a:ea typeface="Montserrat SemiBold"/>
-                <a:cs typeface="Montserrat SemiBold"/>
-                <a:sym typeface="Montserrat SemiBold"/>
+              <a:rPr b="0" i="0" lang="en-US" sz="1275" u="none" cap="none" strike="noStrike">
+                <a:solidFill>
+                  <a:srgbClr val="CDD6F4"/>
+                </a:solidFill>
+                <a:latin typeface="Inter"/>
+                <a:ea typeface="Inter"/>
+                <a:cs typeface="Inter"/>
+                <a:sym typeface="Inter"/>
               </a:rPr>
-              <a:t>Advanced Features</a:t>
+              <a:t>The code architecture is modularly decoupled, meaning it can be expanded to automate other core business procedures:</a:t>
             </a:r>
             <a:endParaRPr b="0" i="0" sz="1400" u="none" cap="none" strike="noStrike">
               <a:solidFill>
@@ -17323,8 +17336,8 @@
         </p:nvSpPr>
         <p:spPr>
           <a:xfrm>
-            <a:off x="6605587" y="3044576"/>
-            <a:ext cx="4519612" cy="501848"/>
+            <a:off x="6605587" y="2673101"/>
+            <a:ext cx="4745593" cy="276225"/>
           </a:xfrm>
           <a:prstGeom prst="rect">
             <a:avLst/>
@@ -17342,32 +17355,32 @@
           <a:p>
             <a:pPr indent="0" lvl="0" marL="0" marR="0" rtl="0" algn="l">
               <a:lnSpc>
-                <a:spcPct val="154980"/>
-              </a:lnSpc>
-              <a:spcBef>
-                <a:spcPts val="0"/>
-              </a:spcBef>
-              <a:spcAft>
-                <a:spcPts val="0"/>
-              </a:spcAft>
-              <a:buClr>
-                <a:srgbClr val="000000"/>
-              </a:buClr>
-              <a:buSzPts val="1275"/>
+                <a:spcPct val="100000"/>
+              </a:lnSpc>
+              <a:spcBef>
+                <a:spcPts val="0"/>
+              </a:spcBef>
+              <a:spcAft>
+                <a:spcPts val="0"/>
+              </a:spcAft>
+              <a:buClr>
+                <a:srgbClr val="000000"/>
+              </a:buClr>
+              <a:buSzPts val="1800"/>
               <a:buFont typeface="Arial"/>
               <a:buNone/>
             </a:pPr>
             <a:r>
-              <a:rPr b="0" i="0" lang="en-US" sz="1275" u="none" cap="none" strike="noStrike">
-                <a:solidFill>
-                  <a:srgbClr val="CDD6F4"/>
-                </a:solidFill>
-                <a:latin typeface="Inter"/>
-                <a:ea typeface="Inter"/>
-                <a:cs typeface="Inter"/>
-                <a:sym typeface="Inter"/>
+              <a:rPr b="0" i="0" lang="en-US" sz="1800" u="none" cap="none" strike="noStrike">
+                <a:solidFill>
+                  <a:srgbClr val="64FFDA"/>
+                </a:solidFill>
+                <a:latin typeface="Montserrat SemiBold"/>
+                <a:ea typeface="Montserrat SemiBold"/>
+                <a:cs typeface="Montserrat SemiBold"/>
+                <a:sym typeface="Montserrat SemiBold"/>
               </a:rPr>
-              <a:t>Future development phases can add enterprise-grade reliability and communication protocols:</a:t>
+              <a:t>Advanced Features</a:t>
             </a:r>
             <a:endParaRPr b="0" i="0" sz="1400" u="none" cap="none" strike="noStrike">
               <a:solidFill>
@@ -17389,8 +17402,8 @@
         </p:nvSpPr>
         <p:spPr>
           <a:xfrm>
-            <a:off x="1400175" y="4054524"/>
-            <a:ext cx="4186237" cy="250924"/>
+            <a:off x="6605587" y="3044576"/>
+            <a:ext cx="4519612" cy="501848"/>
           </a:xfrm>
           <a:prstGeom prst="rect">
             <a:avLst/>
@@ -17433,7 +17446,7 @@
                 <a:cs typeface="Inter"/>
                 <a:sym typeface="Inter"/>
               </a:rPr>
-              <a:t>Expanding to sales orders, shipments, and billing</a:t>
+              <a:t>Future development phases can add enterprise-grade reliability and communication protocols:</a:t>
             </a:r>
             <a:endParaRPr b="0" i="0" sz="1400" u="none" cap="none" strike="noStrike">
               <a:solidFill>
@@ -17455,7 +17468,7 @@
         </p:nvSpPr>
         <p:spPr>
           <a:xfrm>
-            <a:off x="1400175" y="4448323"/>
+            <a:off x="1400175" y="4054524"/>
             <a:ext cx="4186237" cy="250924"/>
           </a:xfrm>
           <a:prstGeom prst="rect">
@@ -17499,7 +17512,7 @@
                 <a:cs typeface="Inter"/>
                 <a:sym typeface="Inter"/>
               </a:rPr>
-              <a:t>Direct cloud / Document Management system sync</a:t>
+              <a:t>Expanding to sales orders, shipments, and billing</a:t>
             </a:r>
             <a:endParaRPr b="0" i="0" sz="1400" u="none" cap="none" strike="noStrike">
               <a:solidFill>
@@ -17521,7 +17534,7 @@
         </p:nvSpPr>
         <p:spPr>
           <a:xfrm>
-            <a:off x="6938962" y="3803600"/>
+            <a:off x="1400175" y="4448323"/>
             <a:ext cx="4186237" cy="250924"/>
           </a:xfrm>
           <a:prstGeom prst="rect">
@@ -17565,7 +17578,7 @@
                 <a:cs typeface="Inter"/>
                 <a:sym typeface="Inter"/>
               </a:rPr>
-              <a:t>Enhanced real-time error logging &amp; fail-safes</a:t>
+              <a:t>Direct cloud / Document Management system sync</a:t>
             </a:r>
             <a:endParaRPr b="0" i="0" sz="1400" u="none" cap="none" strike="noStrike">
               <a:solidFill>
@@ -17587,6 +17600,72 @@
         </p:nvSpPr>
         <p:spPr>
           <a:xfrm>
+            <a:off x="6938962" y="3803600"/>
+            <a:ext cx="4186237" cy="250924"/>
+          </a:xfrm>
+          <a:prstGeom prst="rect">
+            <a:avLst/>
+          </a:prstGeom>
+          <a:noFill/>
+          <a:ln>
+            <a:noFill/>
+          </a:ln>
+        </p:spPr>
+        <p:txBody>
+          <a:bodyPr anchorCtr="0" anchor="t" bIns="0" lIns="0" spcFirstLastPara="1" rIns="0" wrap="square" tIns="0">
+            <a:spAutoFit/>
+          </a:bodyPr>
+          <a:lstStyle/>
+          <a:p>
+            <a:pPr indent="0" lvl="0" marL="0" marR="0" rtl="0" algn="l">
+              <a:lnSpc>
+                <a:spcPct val="154980"/>
+              </a:lnSpc>
+              <a:spcBef>
+                <a:spcPts val="0"/>
+              </a:spcBef>
+              <a:spcAft>
+                <a:spcPts val="0"/>
+              </a:spcAft>
+              <a:buClr>
+                <a:srgbClr val="000000"/>
+              </a:buClr>
+              <a:buSzPts val="1275"/>
+              <a:buFont typeface="Arial"/>
+              <a:buNone/>
+            </a:pPr>
+            <a:r>
+              <a:rPr b="0" i="0" lang="en-US" sz="1275" u="none" cap="none" strike="noStrike">
+                <a:solidFill>
+                  <a:srgbClr val="CDD6F4"/>
+                </a:solidFill>
+                <a:latin typeface="Inter"/>
+                <a:ea typeface="Inter"/>
+                <a:cs typeface="Inter"/>
+                <a:sym typeface="Inter"/>
+              </a:rPr>
+              <a:t>Enhanced real-time error logging &amp; fail-safes</a:t>
+            </a:r>
+            <a:endParaRPr b="0" i="0" sz="1400" u="none" cap="none" strike="noStrike">
+              <a:solidFill>
+                <a:srgbClr val="000000"/>
+              </a:solidFill>
+              <a:latin typeface="Arial"/>
+              <a:ea typeface="Arial"/>
+              <a:cs typeface="Arial"/>
+              <a:sym typeface="Arial"/>
+            </a:endParaRPr>
+          </a:p>
+        </p:txBody>
+      </p:sp>
+      <p:sp>
+        <p:nvSpPr>
+          <p:cNvPr id="308" name="Google Shape;308;p12"/>
+          <p:cNvSpPr txBox="1"/>
+          <p:nvPr/>
+        </p:nvSpPr>
+        <p:spPr>
+          <a:xfrm>
             <a:off x="6938962" y="4197399"/>
             <a:ext cx="4186237" cy="250924"/>
           </a:xfrm>
@@ -17647,7 +17726,7 @@
       </p:sp>
       <p:pic>
         <p:nvPicPr>
-          <p:cNvPr descr="image.png" id="308" name="Google Shape;308;p12"/>
+          <p:cNvPr descr="image.png" id="309" name="Google Shape;309;p12"/>
           <p:cNvPicPr preferRelativeResize="0"/>
           <p:nvPr/>
         </p:nvPicPr>
@@ -17674,7 +17753,7 @@
       </p:pic>
       <p:pic>
         <p:nvPicPr>
-          <p:cNvPr descr="image.png" id="309" name="Google Shape;309;p12"/>
+          <p:cNvPr descr="image.png" id="310" name="Google Shape;310;p12"/>
           <p:cNvPicPr preferRelativeResize="0"/>
           <p:nvPr/>
         </p:nvPicPr>
@@ -17701,7 +17780,7 @@
       </p:pic>
       <p:pic>
         <p:nvPicPr>
-          <p:cNvPr descr="image.png" id="310" name="Google Shape;310;p12"/>
+          <p:cNvPr descr="image.png" id="311" name="Google Shape;311;p12"/>
           <p:cNvPicPr preferRelativeResize="0"/>
           <p:nvPr/>
         </p:nvPicPr>
@@ -17728,7 +17807,7 @@
       </p:pic>
       <p:pic>
         <p:nvPicPr>
-          <p:cNvPr descr="image.png" id="311" name="Google Shape;311;p12"/>
+          <p:cNvPr descr="image.png" id="312" name="Google Shape;312;p12"/>
           <p:cNvPicPr preferRelativeResize="0"/>
           <p:nvPr/>
         </p:nvPicPr>
@@ -17755,7 +17834,7 @@
       </p:pic>
       <p:sp>
         <p:nvSpPr>
-          <p:cNvPr id="312" name="Google Shape;312;p12"/>
+          <p:cNvPr id="313" name="Google Shape;313;p12"/>
           <p:cNvSpPr txBox="1"/>
           <p:nvPr/>
         </p:nvSpPr>
@@ -17821,7 +17900,7 @@
       </p:sp>
       <p:sp>
         <p:nvSpPr>
-          <p:cNvPr id="313" name="Google Shape;313;p12"/>
+          <p:cNvPr id="314" name="Google Shape;314;p12"/>
           <p:cNvSpPr/>
           <p:nvPr/>
         </p:nvSpPr>
@@ -17898,7 +17977,7 @@
     </p:bg>
     <p:spTree>
       <p:nvGrpSpPr>
-        <p:cNvPr id="317" name="Shape 317"/>
+        <p:cNvPr id="318" name="Shape 318"/>
         <p:cNvGrpSpPr/>
         <p:nvPr/>
       </p:nvGrpSpPr>
@@ -17912,7 +17991,7 @@
       </p:grpSpPr>
       <p:pic>
         <p:nvPicPr>
-          <p:cNvPr descr="image.png" id="318" name="Google Shape;318;p13"/>
+          <p:cNvPr descr="image.png" id="319" name="Google Shape;319;p13"/>
           <p:cNvPicPr preferRelativeResize="0"/>
           <p:nvPr/>
         </p:nvPicPr>
@@ -17939,7 +18018,7 @@
       </p:pic>
       <p:sp>
         <p:nvSpPr>
-          <p:cNvPr id="319" name="Google Shape;319;p13"/>
+          <p:cNvPr id="320" name="Google Shape;320;p13"/>
           <p:cNvSpPr txBox="1"/>
           <p:nvPr/>
         </p:nvSpPr>
@@ -17992,72 +18071,6 @@
               <a:t>https://media.licdn.com/dms/image/v2/C4E12AQF8fb_Io9YHyA/article-cover_image-shrink_720_1280/article-cover_image-shrink_720_1280/0/1643913705813?e=2147483647&amp;v=beta&amp;t=SoCBKCyrgtjpmqvXqlk6dfCST0lafo6-SdMPMxve7hM</a:t>
             </a:r>
             <a:endParaRPr b="0" i="0" sz="1000" u="none" cap="none" strike="noStrike">
-              <a:solidFill>
-                <a:srgbClr val="000000"/>
-              </a:solidFill>
-              <a:latin typeface="Arial"/>
-              <a:ea typeface="Arial"/>
-              <a:cs typeface="Arial"/>
-              <a:sym typeface="Arial"/>
-            </a:endParaRPr>
-          </a:p>
-        </p:txBody>
-      </p:sp>
-      <p:sp>
-        <p:nvSpPr>
-          <p:cNvPr id="320" name="Google Shape;320;p13"/>
-          <p:cNvSpPr txBox="1"/>
-          <p:nvPr/>
-        </p:nvSpPr>
-        <p:spPr>
-          <a:xfrm>
-            <a:off x="2777025" y="2482334"/>
-            <a:ext cx="9553500" cy="184800"/>
-          </a:xfrm>
-          <a:prstGeom prst="rect">
-            <a:avLst/>
-          </a:prstGeom>
-          <a:noFill/>
-          <a:ln>
-            <a:noFill/>
-          </a:ln>
-        </p:spPr>
-        <p:txBody>
-          <a:bodyPr anchorCtr="0" anchor="t" bIns="0" lIns="0" spcFirstLastPara="1" rIns="0" wrap="square" tIns="0">
-            <a:spAutoFit/>
-          </a:bodyPr>
-          <a:lstStyle/>
-          <a:p>
-            <a:pPr indent="0" lvl="0" marL="0" marR="0" rtl="0" algn="l">
-              <a:lnSpc>
-                <a:spcPct val="160000"/>
-              </a:lnSpc>
-              <a:spcBef>
-                <a:spcPts val="0"/>
-              </a:spcBef>
-              <a:spcAft>
-                <a:spcPts val="0"/>
-              </a:spcAft>
-              <a:buClr>
-                <a:srgbClr val="000000"/>
-              </a:buClr>
-              <a:buSzPts val="1200"/>
-              <a:buFont typeface="Arial"/>
-              <a:buNone/>
-            </a:pPr>
-            <a:r>
-              <a:rPr b="0" i="0" lang="en-US" sz="1200" u="none" cap="none" strike="noStrike">
-                <a:solidFill>
-                  <a:srgbClr val="CDD6F4"/>
-                </a:solidFill>
-                <a:latin typeface="Inter"/>
-                <a:ea typeface="Inter"/>
-                <a:cs typeface="Inter"/>
-                <a:sym typeface="Inter"/>
-              </a:rPr>
-              <a:t>Source: https://media.licdn.com/</a:t>
-            </a:r>
-            <a:endParaRPr b="0" i="0" sz="1400" u="none" cap="none" strike="noStrike">
               <a:solidFill>
                 <a:srgbClr val="000000"/>
               </a:solidFill>
@@ -18077,8 +18090,8 @@
         </p:nvSpPr>
         <p:spPr>
           <a:xfrm>
-            <a:off x="962025" y="581025"/>
-            <a:ext cx="10981500" cy="461700"/>
+            <a:off x="2777025" y="2482334"/>
+            <a:ext cx="9553500" cy="184800"/>
           </a:xfrm>
           <a:prstGeom prst="rect">
             <a:avLst/>
@@ -18096,32 +18109,32 @@
           <a:p>
             <a:pPr indent="0" lvl="0" marL="0" marR="0" rtl="0" algn="l">
               <a:lnSpc>
-                <a:spcPct val="100000"/>
-              </a:lnSpc>
-              <a:spcBef>
-                <a:spcPts val="0"/>
-              </a:spcBef>
-              <a:spcAft>
-                <a:spcPts val="0"/>
-              </a:spcAft>
-              <a:buClr>
-                <a:srgbClr val="000000"/>
-              </a:buClr>
-              <a:buSzPts val="3000"/>
+                <a:spcPct val="160000"/>
+              </a:lnSpc>
+              <a:spcBef>
+                <a:spcPts val="0"/>
+              </a:spcBef>
+              <a:spcAft>
+                <a:spcPts val="0"/>
+              </a:spcAft>
+              <a:buClr>
+                <a:srgbClr val="000000"/>
+              </a:buClr>
+              <a:buSzPts val="1200"/>
               <a:buFont typeface="Arial"/>
               <a:buNone/>
             </a:pPr>
             <a:r>
-              <a:rPr b="1" i="0" lang="en-US" sz="3000" u="none" cap="none" strike="noStrike">
-                <a:solidFill>
-                  <a:srgbClr val="FFFFFF"/>
-                </a:solidFill>
-                <a:latin typeface="Montserrat"/>
-                <a:ea typeface="Montserrat"/>
-                <a:cs typeface="Montserrat"/>
-                <a:sym typeface="Montserrat"/>
+              <a:rPr b="0" i="0" lang="en-US" sz="1200" u="none" cap="none" strike="noStrike">
+                <a:solidFill>
+                  <a:srgbClr val="CDD6F4"/>
+                </a:solidFill>
+                <a:latin typeface="Inter"/>
+                <a:ea typeface="Inter"/>
+                <a:cs typeface="Inter"/>
+                <a:sym typeface="Inter"/>
               </a:rPr>
-              <a:t>Image Sources</a:t>
+              <a:t>Source: https://media.licdn.com/</a:t>
             </a:r>
             <a:endParaRPr b="0" i="0" sz="1400" u="none" cap="none" strike="noStrike">
               <a:solidFill>
@@ -18138,6 +18151,72 @@
       <p:sp>
         <p:nvSpPr>
           <p:cNvPr id="322" name="Google Shape;322;p13"/>
+          <p:cNvSpPr txBox="1"/>
+          <p:nvPr/>
+        </p:nvSpPr>
+        <p:spPr>
+          <a:xfrm>
+            <a:off x="962025" y="581025"/>
+            <a:ext cx="10981500" cy="461700"/>
+          </a:xfrm>
+          <a:prstGeom prst="rect">
+            <a:avLst/>
+          </a:prstGeom>
+          <a:noFill/>
+          <a:ln>
+            <a:noFill/>
+          </a:ln>
+        </p:spPr>
+        <p:txBody>
+          <a:bodyPr anchorCtr="0" anchor="t" bIns="0" lIns="0" spcFirstLastPara="1" rIns="0" wrap="square" tIns="0">
+            <a:spAutoFit/>
+          </a:bodyPr>
+          <a:lstStyle/>
+          <a:p>
+            <a:pPr indent="0" lvl="0" marL="0" marR="0" rtl="0" algn="l">
+              <a:lnSpc>
+                <a:spcPct val="100000"/>
+              </a:lnSpc>
+              <a:spcBef>
+                <a:spcPts val="0"/>
+              </a:spcBef>
+              <a:spcAft>
+                <a:spcPts val="0"/>
+              </a:spcAft>
+              <a:buClr>
+                <a:srgbClr val="000000"/>
+              </a:buClr>
+              <a:buSzPts val="3000"/>
+              <a:buFont typeface="Arial"/>
+              <a:buNone/>
+            </a:pPr>
+            <a:r>
+              <a:rPr b="1" i="0" lang="en-US" sz="3000" u="none" cap="none" strike="noStrike">
+                <a:solidFill>
+                  <a:srgbClr val="FFFFFF"/>
+                </a:solidFill>
+                <a:latin typeface="Montserrat"/>
+                <a:ea typeface="Montserrat"/>
+                <a:cs typeface="Montserrat"/>
+                <a:sym typeface="Montserrat"/>
+              </a:rPr>
+              <a:t>Image Sources</a:t>
+            </a:r>
+            <a:endParaRPr b="0" i="0" sz="1400" u="none" cap="none" strike="noStrike">
+              <a:solidFill>
+                <a:srgbClr val="000000"/>
+              </a:solidFill>
+              <a:latin typeface="Arial"/>
+              <a:ea typeface="Arial"/>
+              <a:cs typeface="Arial"/>
+              <a:sym typeface="Arial"/>
+            </a:endParaRPr>
+          </a:p>
+        </p:txBody>
+      </p:sp>
+      <p:sp>
+        <p:nvSpPr>
+          <p:cNvPr id="323" name="Google Shape;323;p13"/>
           <p:cNvSpPr/>
           <p:nvPr/>
         </p:nvSpPr>
@@ -18196,7 +18275,7 @@
       </p:sp>
       <p:pic>
         <p:nvPicPr>
-          <p:cNvPr id="323" name="Google Shape;323;p13"/>
+          <p:cNvPr id="324" name="Google Shape;324;p13"/>
           <p:cNvPicPr preferRelativeResize="0"/>
           <p:nvPr/>
         </p:nvPicPr>
@@ -18223,7 +18302,7 @@
       </p:pic>
       <p:sp>
         <p:nvSpPr>
-          <p:cNvPr id="324" name="Google Shape;324;p13"/>
+          <p:cNvPr id="325" name="Google Shape;325;p13"/>
           <p:cNvSpPr txBox="1"/>
           <p:nvPr/>
         </p:nvSpPr>
@@ -18289,7 +18368,7 @@
       </p:sp>
       <p:sp>
         <p:nvSpPr>
-          <p:cNvPr id="325" name="Google Shape;325;p13"/>
+          <p:cNvPr id="326" name="Google Shape;326;p13"/>
           <p:cNvSpPr txBox="1"/>
           <p:nvPr/>
         </p:nvSpPr>
@@ -18355,7 +18434,7 @@
       </p:sp>
       <p:pic>
         <p:nvPicPr>
-          <p:cNvPr id="326" name="Google Shape;326;p13"/>
+          <p:cNvPr id="327" name="Google Shape;327;p13"/>
           <p:cNvPicPr preferRelativeResize="0"/>
           <p:nvPr/>
         </p:nvPicPr>
@@ -19542,7 +19621,7 @@
               <a:buNone/>
             </a:pPr>
             <a:r>
-              <a:rPr b="0" i="0" lang="en-US" sz="1650" u="none" cap="none" strike="noStrike">
+              <a:rPr lang="en-US" sz="1650">
                 <a:solidFill>
                   <a:srgbClr val="64FFDA"/>
                 </a:solidFill>
@@ -19551,7 +19630,7 @@
                 <a:cs typeface="Montserrat SemiBold"/>
                 <a:sym typeface="Montserrat SemiBold"/>
               </a:rPr>
-              <a:t>Strict Human Governance</a:t>
+              <a:t>Engineering Ownership </a:t>
             </a:r>
             <a:endParaRPr b="0" i="0" sz="1400" u="none" cap="none" strike="noStrike">
               <a:solidFill>
@@ -20427,7 +20506,7 @@
             <a:tbl>
               <a:tblPr bandRow="1" firstRow="1">
                 <a:noFill/>
-                <a:tableStyleId>{C4AB5C4D-3846-4573-9431-B61F419FFCB4}</a:tableStyleId>
+                <a:tableStyleId>{7D95C02A-70E6-4CEF-ACC8-0583C205ED59}</a:tableStyleId>
               </a:tblPr>
               <a:tblGrid>
                 <a:gridCol w="1228725"/>
@@ -27180,7 +27259,7 @@
                 <a:cs typeface="Inter"/>
                 <a:sym typeface="Inter"/>
               </a:rPr>
-              <a:t>I </a:t>
+              <a:t> </a:t>
             </a:r>
             <a:r>
               <a:rPr lang="en-US" sz="900">
@@ -27204,7 +27283,7 @@
                 <a:cs typeface="Inter"/>
                 <a:sym typeface="Inter"/>
               </a:rPr>
-              <a:t>to automatically detect and dismiss OLE dialogs during unattended SAP automation. </a:t>
+              <a:t>to detect and dismiss OLE dialogs during unattended SAP automation. </a:t>
             </a:r>
             <a:endParaRPr b="0" i="0" sz="1400" u="none" cap="none" strike="noStrike">
               <a:solidFill>

</xml_diff>